<commit_message>
feat: complete Cut and Sub editor unification
Share timeline, mode control, operation, settings, and focus contracts across Cut and Sub. Expand documentation and regression coverage, and show user-facing titles with item counts during Cut export.
</commit_message>
<xml_diff>
--- a/assets/docs-image-source.pptx
+++ b/assets/docs-image-source.pptx
@@ -1,14 +1,19 @@
 
 <file path=ppt/presentation.xml><?xml version="1.0" encoding="utf-8"?>
-<p:presentation xmlns:a="http://schemas.openxmlformats.org/drawingml/2006/main" xmlns:r="http://schemas.openxmlformats.org/officeDocument/2006/relationships" xmlns:p="http://schemas.openxmlformats.org/presentationml/2006/main" saveSubsetFonts="1">
+<p:presentation xmlns:a="http://schemas.openxmlformats.org/drawingml/2006/main" xmlns:r="http://schemas.openxmlformats.org/officeDocument/2006/relationships" xmlns:p="http://schemas.openxmlformats.org/presentationml/2006/main">
   <p:sldMasterIdLst>
     <p:sldMasterId id="2147483648" r:id="rId1"/>
   </p:sldMasterIdLst>
+  <p:notesMasterIdLst>
+    <p:notesMasterId r:id="rId8"/>
+  </p:notesMasterIdLst>
   <p:sldIdLst>
     <p:sldId id="256" r:id="rId2"/>
     <p:sldId id="257" r:id="rId3"/>
     <p:sldId id="258" r:id="rId4"/>
     <p:sldId id="259" r:id="rId5"/>
+    <p:sldId id="260" r:id="rId6"/>
+    <p:sldId id="261" r:id="rId7"/>
   </p:sldIdLst>
   <p:sldSz cx="12192000" cy="6858000"/>
   <p:notesSz cx="6858000" cy="9144000"/>
@@ -115,6 +120,669 @@
 </p:presentation>
 </file>
 
+<file path=ppt/notesMasters/notesMaster1.xml><?xml version="1.0" encoding="utf-8"?>
+<p:notesMaster xmlns:a="http://schemas.openxmlformats.org/drawingml/2006/main" xmlns:r="http://schemas.openxmlformats.org/officeDocument/2006/relationships" xmlns:p="http://schemas.openxmlformats.org/presentationml/2006/main">
+  <p:cSld>
+    <p:bg>
+      <p:bgRef idx="1001">
+        <a:schemeClr val="bg1"/>
+      </p:bgRef>
+    </p:bg>
+    <p:spTree>
+      <p:nvGrpSpPr>
+        <p:cNvPr id="1" name=""/>
+        <p:cNvGrpSpPr/>
+        <p:nvPr/>
+      </p:nvGrpSpPr>
+      <p:grpSpPr>
+        <a:xfrm>
+          <a:off x="0" y="0"/>
+          <a:ext cx="0" cy="0"/>
+          <a:chOff x="0" y="0"/>
+          <a:chExt cx="0" cy="0"/>
+        </a:xfrm>
+      </p:grpSpPr>
+      <p:sp>
+        <p:nvSpPr>
+          <p:cNvPr id="2" name="Header Placeholder"/>
+          <p:cNvSpPr>
+            <a:spLocks noGrp="1"/>
+          </p:cNvSpPr>
+          <p:nvPr>
+            <p:ph type="hdr" sz="quarter"/>
+          </p:nvPr>
+        </p:nvSpPr>
+        <p:spPr>
+          <a:prstGeom prst="rect">
+            <a:avLst/>
+          </a:prstGeom>
+        </p:spPr>
+        <p:txBody>
+          <a:bodyPr/>
+          <a:lstStyle/>
+          <a:p>
+            <a:endParaRPr/>
+          </a:p>
+        </p:txBody>
+      </p:sp>
+      <p:sp>
+        <p:nvSpPr>
+          <p:cNvPr id="3" name="Date Placeholder"/>
+          <p:cNvSpPr>
+            <a:spLocks noGrp="1"/>
+          </p:cNvSpPr>
+          <p:nvPr>
+            <p:ph type="dt" sz="quarter" idx="1"/>
+          </p:nvPr>
+        </p:nvSpPr>
+        <p:spPr>
+          <a:prstGeom prst="rect">
+            <a:avLst/>
+          </a:prstGeom>
+        </p:spPr>
+        <p:txBody>
+          <a:bodyPr/>
+          <a:lstStyle/>
+          <a:p>
+            <a:endParaRPr/>
+          </a:p>
+        </p:txBody>
+      </p:sp>
+      <p:sp>
+        <p:nvSpPr>
+          <p:cNvPr id="4" name="Slide Image Placeholder"/>
+          <p:cNvSpPr>
+            <a:spLocks noGrp="1" noRot="1" noChangeAspect="1"/>
+          </p:cNvSpPr>
+          <p:nvPr>
+            <p:ph type="sldImg" idx="2"/>
+          </p:nvPr>
+        </p:nvSpPr>
+        <p:spPr>
+          <a:prstGeom prst="rect">
+            <a:avLst/>
+          </a:prstGeom>
+        </p:spPr>
+        <p:txBody>
+          <a:bodyPr/>
+          <a:lstStyle/>
+          <a:p>
+            <a:endParaRPr/>
+          </a:p>
+        </p:txBody>
+      </p:sp>
+      <p:sp>
+        <p:nvSpPr>
+          <p:cNvPr id="5" name="Notes Placeholder"/>
+          <p:cNvSpPr>
+            <a:spLocks noGrp="1"/>
+          </p:cNvSpPr>
+          <p:nvPr>
+            <p:ph type="body" sz="quarter" idx="3"/>
+          </p:nvPr>
+        </p:nvSpPr>
+        <p:spPr>
+          <a:prstGeom prst="rect">
+            <a:avLst/>
+          </a:prstGeom>
+        </p:spPr>
+        <p:txBody>
+          <a:bodyPr/>
+          <a:lstStyle/>
+          <a:p>
+            <a:endParaRPr/>
+          </a:p>
+        </p:txBody>
+      </p:sp>
+      <p:sp>
+        <p:nvSpPr>
+          <p:cNvPr id="6" name="Footer Placeholder"/>
+          <p:cNvSpPr>
+            <a:spLocks noGrp="1"/>
+          </p:cNvSpPr>
+          <p:nvPr>
+            <p:ph type="ftr" sz="quarter" idx="4"/>
+          </p:nvPr>
+        </p:nvSpPr>
+        <p:spPr>
+          <a:prstGeom prst="rect">
+            <a:avLst/>
+          </a:prstGeom>
+        </p:spPr>
+        <p:txBody>
+          <a:bodyPr/>
+          <a:lstStyle/>
+          <a:p>
+            <a:endParaRPr/>
+          </a:p>
+        </p:txBody>
+      </p:sp>
+      <p:sp>
+        <p:nvSpPr>
+          <p:cNvPr id="7" name="Slide Number Placeholder"/>
+          <p:cNvSpPr>
+            <a:spLocks noGrp="1"/>
+          </p:cNvSpPr>
+          <p:nvPr>
+            <p:ph type="sldNum" sz="quarter" idx="5"/>
+          </p:nvPr>
+        </p:nvSpPr>
+        <p:spPr>
+          <a:prstGeom prst="rect">
+            <a:avLst/>
+          </a:prstGeom>
+        </p:spPr>
+        <p:txBody>
+          <a:bodyPr/>
+          <a:lstStyle/>
+          <a:p>
+            <a:endParaRPr/>
+          </a:p>
+        </p:txBody>
+      </p:sp>
+    </p:spTree>
+  </p:cSld>
+  <p:clrMap bg1="lt1" tx1="dk1" bg2="lt2" tx2="dk2" accent1="accent1" accent2="accent2" accent3="accent3" accent4="accent4" accent5="accent5" accent6="accent6" hlink="hlink" folHlink="folHlink"/>
+  <p:notesStyle>
+    <a:lvl1pPr marL="0" algn="l" defTabSz="914400" rtl="0" eaLnBrk="1" latinLnBrk="0" hangingPunct="1">
+      <a:defRPr sz="1200" kern="1200"/>
+    </a:lvl1pPr>
+  </p:notesStyle>
+</p:notesMaster>
+</file>
+
+<file path=ppt/notesSlides/notesSlide1.xml><?xml version="1.0" encoding="utf-8"?>
+<p:notes xmlns:a="http://schemas.openxmlformats.org/drawingml/2006/main" xmlns:r="http://schemas.openxmlformats.org/officeDocument/2006/relationships" xmlns:p="http://schemas.openxmlformats.org/presentationml/2006/main">
+  <p:cSld>
+    <p:spTree>
+      <p:nvGrpSpPr>
+        <p:cNvPr id="1" name=""/>
+        <p:cNvGrpSpPr/>
+        <p:nvPr/>
+      </p:nvGrpSpPr>
+      <p:grpSpPr>
+        <a:xfrm>
+          <a:off x="0" y="0"/>
+          <a:ext cx="0" cy="0"/>
+          <a:chOff x="0" y="0"/>
+          <a:chExt cx="0" cy="0"/>
+        </a:xfrm>
+      </p:grpSpPr>
+      <p:sp>
+        <p:nvSpPr>
+          <p:cNvPr id="2" name="Slide Image Placeholder 1"/>
+          <p:cNvSpPr>
+            <a:spLocks noGrp="1" noRot="1" noChangeAspect="1"/>
+          </p:cNvSpPr>
+          <p:nvPr>
+            <p:ph type="sldImg"/>
+          </p:nvPr>
+        </p:nvSpPr>
+        <p:spPr/>
+      </p:sp>
+      <p:sp>
+        <p:nvSpPr>
+          <p:cNvPr id="3" name="Notes Placeholder 2"/>
+          <p:cNvSpPr>
+            <a:spLocks noGrp="1"/>
+          </p:cNvSpPr>
+          <p:nvPr>
+            <p:ph type="body" idx="1"/>
+          </p:nvPr>
+        </p:nvSpPr>
+        <p:spPr/>
+        <p:txBody>
+          <a:bodyPr/>
+          <a:lstStyle/>
+          <a:p>
+            <a:r>
+              <a:t>[Sources]</a:t>
+            </a:r>
+          </a:p>
+          <a:p>
+            <a:r>
+              <a:t>- Local Songcut capture using testdata/【歌枠／弾き語り】会いに来てくれますか？初見さんも大歓迎！ゆるっと歌います！🎤🎸Singing Stream【#弾き語り #Vsinger】#からくりんね [_WEzOut0NfY].mp4</a:t>
+            </a:r>
+          </a:p>
+        </p:txBody>
+      </p:sp>
+      <p:sp>
+        <p:nvSpPr>
+          <p:cNvPr id="4" name="Slide Number Placeholder 3"/>
+          <p:cNvSpPr>
+            <a:spLocks noGrp="1"/>
+          </p:cNvSpPr>
+          <p:nvPr>
+            <p:ph type="sldNum" idx="5"/>
+          </p:nvPr>
+        </p:nvSpPr>
+        <p:spPr/>
+        <p:txBody>
+          <a:bodyPr/>
+          <a:lstStyle/>
+          <a:p>
+            <a:endParaRPr/>
+          </a:p>
+        </p:txBody>
+      </p:sp>
+    </p:spTree>
+  </p:cSld>
+  <p:clrMapOvr>
+    <a:masterClrMapping/>
+  </p:clrMapOvr>
+</p:notes>
+</file>
+
+<file path=ppt/notesSlides/notesSlide2.xml><?xml version="1.0" encoding="utf-8"?>
+<p:notes xmlns:a="http://schemas.openxmlformats.org/drawingml/2006/main" xmlns:r="http://schemas.openxmlformats.org/officeDocument/2006/relationships" xmlns:p="http://schemas.openxmlformats.org/presentationml/2006/main">
+  <p:cSld>
+    <p:spTree>
+      <p:nvGrpSpPr>
+        <p:cNvPr id="1" name=""/>
+        <p:cNvGrpSpPr/>
+        <p:nvPr/>
+      </p:nvGrpSpPr>
+      <p:grpSpPr>
+        <a:xfrm>
+          <a:off x="0" y="0"/>
+          <a:ext cx="0" cy="0"/>
+          <a:chOff x="0" y="0"/>
+          <a:chExt cx="0" cy="0"/>
+        </a:xfrm>
+      </p:grpSpPr>
+      <p:sp>
+        <p:nvSpPr>
+          <p:cNvPr id="2" name="Slide Image Placeholder 1"/>
+          <p:cNvSpPr>
+            <a:spLocks noGrp="1" noRot="1" noChangeAspect="1"/>
+          </p:cNvSpPr>
+          <p:nvPr>
+            <p:ph type="sldImg"/>
+          </p:nvPr>
+        </p:nvSpPr>
+        <p:spPr/>
+      </p:sp>
+      <p:sp>
+        <p:nvSpPr>
+          <p:cNvPr id="3" name="Notes Placeholder 2"/>
+          <p:cNvSpPr>
+            <a:spLocks noGrp="1"/>
+          </p:cNvSpPr>
+          <p:nvPr>
+            <p:ph type="body" idx="1"/>
+          </p:nvPr>
+        </p:nvSpPr>
+        <p:spPr/>
+        <p:txBody>
+          <a:bodyPr/>
+          <a:lstStyle/>
+          <a:p>
+            <a:r>
+              <a:t>[Sources]</a:t>
+            </a:r>
+          </a:p>
+          <a:p>
+            <a:r>
+              <a:t>- Local Songcut capture using testdata/【歌枠／弾き語り】会いに来てくれますか？初見さんも大歓迎！ゆるっと歌います！🎤🎸Singing Stream【#弾き語り #Vsinger】#からくりんね [_WEzOut0NfY].mp4</a:t>
+            </a:r>
+          </a:p>
+        </p:txBody>
+      </p:sp>
+      <p:sp>
+        <p:nvSpPr>
+          <p:cNvPr id="4" name="Slide Number Placeholder 3"/>
+          <p:cNvSpPr>
+            <a:spLocks noGrp="1"/>
+          </p:cNvSpPr>
+          <p:nvPr>
+            <p:ph type="sldNum" idx="5"/>
+          </p:nvPr>
+        </p:nvSpPr>
+        <p:spPr/>
+        <p:txBody>
+          <a:bodyPr/>
+          <a:lstStyle/>
+          <a:p>
+            <a:endParaRPr/>
+          </a:p>
+        </p:txBody>
+      </p:sp>
+    </p:spTree>
+  </p:cSld>
+  <p:clrMapOvr>
+    <a:masterClrMapping/>
+  </p:clrMapOvr>
+</p:notes>
+</file>
+
+<file path=ppt/notesSlides/notesSlide3.xml><?xml version="1.0" encoding="utf-8"?>
+<p:notes xmlns:a="http://schemas.openxmlformats.org/drawingml/2006/main" xmlns:r="http://schemas.openxmlformats.org/officeDocument/2006/relationships" xmlns:p="http://schemas.openxmlformats.org/presentationml/2006/main">
+  <p:cSld>
+    <p:spTree>
+      <p:nvGrpSpPr>
+        <p:cNvPr id="1" name=""/>
+        <p:cNvGrpSpPr/>
+        <p:nvPr/>
+      </p:nvGrpSpPr>
+      <p:grpSpPr>
+        <a:xfrm>
+          <a:off x="0" y="0"/>
+          <a:ext cx="0" cy="0"/>
+          <a:chOff x="0" y="0"/>
+          <a:chExt cx="0" cy="0"/>
+        </a:xfrm>
+      </p:grpSpPr>
+      <p:sp>
+        <p:nvSpPr>
+          <p:cNvPr id="2" name="Slide Image Placeholder 1"/>
+          <p:cNvSpPr>
+            <a:spLocks noGrp="1" noRot="1" noChangeAspect="1"/>
+          </p:cNvSpPr>
+          <p:nvPr>
+            <p:ph type="sldImg"/>
+          </p:nvPr>
+        </p:nvSpPr>
+        <p:spPr/>
+      </p:sp>
+      <p:sp>
+        <p:nvSpPr>
+          <p:cNvPr id="3" name="Notes Placeholder 2"/>
+          <p:cNvSpPr>
+            <a:spLocks noGrp="1"/>
+          </p:cNvSpPr>
+          <p:nvPr>
+            <p:ph type="body" idx="1"/>
+          </p:nvPr>
+        </p:nvSpPr>
+        <p:spPr/>
+        <p:txBody>
+          <a:bodyPr/>
+          <a:lstStyle/>
+          <a:p>
+            <a:r>
+              <a:t>[Sources]</a:t>
+            </a:r>
+          </a:p>
+          <a:p>
+            <a:r>
+              <a:t>- Local Songcut capture using testdata/【歌枠／弾き語り】会いに来てくれますか？初見さんも大歓迎！ゆるっと歌います！🎤🎸Singing Stream【#弾き語り #Vsinger】#からくりんね [_WEzOut0NfY].mp4</a:t>
+            </a:r>
+          </a:p>
+        </p:txBody>
+      </p:sp>
+      <p:sp>
+        <p:nvSpPr>
+          <p:cNvPr id="4" name="Slide Number Placeholder 3"/>
+          <p:cNvSpPr>
+            <a:spLocks noGrp="1"/>
+          </p:cNvSpPr>
+          <p:nvPr>
+            <p:ph type="sldNum" idx="5"/>
+          </p:nvPr>
+        </p:nvSpPr>
+        <p:spPr/>
+        <p:txBody>
+          <a:bodyPr/>
+          <a:lstStyle/>
+          <a:p>
+            <a:endParaRPr/>
+          </a:p>
+        </p:txBody>
+      </p:sp>
+    </p:spTree>
+  </p:cSld>
+  <p:clrMapOvr>
+    <a:masterClrMapping/>
+  </p:clrMapOvr>
+</p:notes>
+</file>
+
+<file path=ppt/notesSlides/notesSlide4.xml><?xml version="1.0" encoding="utf-8"?>
+<p:notes xmlns:a="http://schemas.openxmlformats.org/drawingml/2006/main" xmlns:r="http://schemas.openxmlformats.org/officeDocument/2006/relationships" xmlns:p="http://schemas.openxmlformats.org/presentationml/2006/main">
+  <p:cSld>
+    <p:spTree>
+      <p:nvGrpSpPr>
+        <p:cNvPr id="1" name=""/>
+        <p:cNvGrpSpPr/>
+        <p:nvPr/>
+      </p:nvGrpSpPr>
+      <p:grpSpPr>
+        <a:xfrm>
+          <a:off x="0" y="0"/>
+          <a:ext cx="0" cy="0"/>
+          <a:chOff x="0" y="0"/>
+          <a:chExt cx="0" cy="0"/>
+        </a:xfrm>
+      </p:grpSpPr>
+      <p:sp>
+        <p:nvSpPr>
+          <p:cNvPr id="2" name="Slide Image Placeholder 1"/>
+          <p:cNvSpPr>
+            <a:spLocks noGrp="1" noRot="1" noChangeAspect="1"/>
+          </p:cNvSpPr>
+          <p:nvPr>
+            <p:ph type="sldImg"/>
+          </p:nvPr>
+        </p:nvSpPr>
+        <p:spPr/>
+      </p:sp>
+      <p:sp>
+        <p:nvSpPr>
+          <p:cNvPr id="3" name="Notes Placeholder 2"/>
+          <p:cNvSpPr>
+            <a:spLocks noGrp="1"/>
+          </p:cNvSpPr>
+          <p:nvPr>
+            <p:ph type="body" idx="1"/>
+          </p:nvPr>
+        </p:nvSpPr>
+        <p:spPr/>
+        <p:txBody>
+          <a:bodyPr/>
+          <a:lstStyle/>
+          <a:p>
+            <a:r>
+              <a:t>[Sources]</a:t>
+            </a:r>
+          </a:p>
+          <a:p>
+            <a:r>
+              <a:t>- Local Songcut capture using testdata/【歌枠／弾き語り】会いに来てくれますか？初見さんも大歓迎！ゆるっと歌います！🎤🎸Singing Stream【#弾き語り #Vsinger】#からくりんね [_WEzOut0NfY].mp4</a:t>
+            </a:r>
+          </a:p>
+        </p:txBody>
+      </p:sp>
+      <p:sp>
+        <p:nvSpPr>
+          <p:cNvPr id="4" name="Slide Number Placeholder 3"/>
+          <p:cNvSpPr>
+            <a:spLocks noGrp="1"/>
+          </p:cNvSpPr>
+          <p:nvPr>
+            <p:ph type="sldNum" idx="5"/>
+          </p:nvPr>
+        </p:nvSpPr>
+        <p:spPr/>
+        <p:txBody>
+          <a:bodyPr/>
+          <a:lstStyle/>
+          <a:p>
+            <a:endParaRPr/>
+          </a:p>
+        </p:txBody>
+      </p:sp>
+    </p:spTree>
+  </p:cSld>
+  <p:clrMapOvr>
+    <a:masterClrMapping/>
+  </p:clrMapOvr>
+</p:notes>
+</file>
+
+<file path=ppt/notesSlides/notesSlide5.xml><?xml version="1.0" encoding="utf-8"?>
+<p:notes xmlns:a="http://schemas.openxmlformats.org/drawingml/2006/main" xmlns:r="http://schemas.openxmlformats.org/officeDocument/2006/relationships" xmlns:p="http://schemas.openxmlformats.org/presentationml/2006/main">
+  <p:cSld>
+    <p:spTree>
+      <p:nvGrpSpPr>
+        <p:cNvPr id="1" name=""/>
+        <p:cNvGrpSpPr/>
+        <p:nvPr/>
+      </p:nvGrpSpPr>
+      <p:grpSpPr>
+        <a:xfrm>
+          <a:off x="0" y="0"/>
+          <a:ext cx="0" cy="0"/>
+          <a:chOff x="0" y="0"/>
+          <a:chExt cx="0" cy="0"/>
+        </a:xfrm>
+      </p:grpSpPr>
+      <p:sp>
+        <p:nvSpPr>
+          <p:cNvPr id="2" name="Slide Image Placeholder 1"/>
+          <p:cNvSpPr>
+            <a:spLocks noGrp="1" noRot="1" noChangeAspect="1"/>
+          </p:cNvSpPr>
+          <p:nvPr>
+            <p:ph type="sldImg"/>
+          </p:nvPr>
+        </p:nvSpPr>
+        <p:spPr/>
+      </p:sp>
+      <p:sp>
+        <p:nvSpPr>
+          <p:cNvPr id="3" name="Notes Placeholder 2"/>
+          <p:cNvSpPr>
+            <a:spLocks noGrp="1"/>
+          </p:cNvSpPr>
+          <p:nvPr>
+            <p:ph type="body" idx="1"/>
+          </p:nvPr>
+        </p:nvSpPr>
+        <p:spPr/>
+        <p:txBody>
+          <a:bodyPr/>
+          <a:lstStyle/>
+          <a:p>
+            <a:r>
+              <a:t>[Sources]</a:t>
+            </a:r>
+          </a:p>
+          <a:p>
+            <a:r>
+              <a:t>- Local Songcut capture using testdata/02_「星の消えた夜に」 - Aimer.webm</a:t>
+            </a:r>
+          </a:p>
+        </p:txBody>
+      </p:sp>
+      <p:sp>
+        <p:nvSpPr>
+          <p:cNvPr id="4" name="Slide Number Placeholder 3"/>
+          <p:cNvSpPr>
+            <a:spLocks noGrp="1"/>
+          </p:cNvSpPr>
+          <p:nvPr>
+            <p:ph type="sldNum" idx="5"/>
+          </p:nvPr>
+        </p:nvSpPr>
+        <p:spPr/>
+        <p:txBody>
+          <a:bodyPr/>
+          <a:lstStyle/>
+          <a:p>
+            <a:endParaRPr/>
+          </a:p>
+        </p:txBody>
+      </p:sp>
+    </p:spTree>
+  </p:cSld>
+  <p:clrMapOvr>
+    <a:masterClrMapping/>
+  </p:clrMapOvr>
+</p:notes>
+</file>
+
+<file path=ppt/notesSlides/notesSlide6.xml><?xml version="1.0" encoding="utf-8"?>
+<p:notes xmlns:a="http://schemas.openxmlformats.org/drawingml/2006/main" xmlns:r="http://schemas.openxmlformats.org/officeDocument/2006/relationships" xmlns:p="http://schemas.openxmlformats.org/presentationml/2006/main">
+  <p:cSld>
+    <p:spTree>
+      <p:nvGrpSpPr>
+        <p:cNvPr id="1" name=""/>
+        <p:cNvGrpSpPr/>
+        <p:nvPr/>
+      </p:nvGrpSpPr>
+      <p:grpSpPr>
+        <a:xfrm>
+          <a:off x="0" y="0"/>
+          <a:ext cx="0" cy="0"/>
+          <a:chOff x="0" y="0"/>
+          <a:chExt cx="0" cy="0"/>
+        </a:xfrm>
+      </p:grpSpPr>
+      <p:sp>
+        <p:nvSpPr>
+          <p:cNvPr id="2" name="Slide Image Placeholder 1"/>
+          <p:cNvSpPr>
+            <a:spLocks noGrp="1" noRot="1" noChangeAspect="1"/>
+          </p:cNvSpPr>
+          <p:nvPr>
+            <p:ph type="sldImg"/>
+          </p:nvPr>
+        </p:nvSpPr>
+        <p:spPr/>
+      </p:sp>
+      <p:sp>
+        <p:nvSpPr>
+          <p:cNvPr id="3" name="Notes Placeholder 2"/>
+          <p:cNvSpPr>
+            <a:spLocks noGrp="1"/>
+          </p:cNvSpPr>
+          <p:nvPr>
+            <p:ph type="body" idx="1"/>
+          </p:nvPr>
+        </p:nvSpPr>
+        <p:spPr/>
+        <p:txBody>
+          <a:bodyPr/>
+          <a:lstStyle/>
+          <a:p>
+            <a:r>
+              <a:t>[Sources]</a:t>
+            </a:r>
+          </a:p>
+          <a:p>
+            <a:r>
+              <a:t>- Local Songcut capture using testdata/02_「星の消えた夜に」 - Aimer.webm</a:t>
+            </a:r>
+          </a:p>
+        </p:txBody>
+      </p:sp>
+      <p:sp>
+        <p:nvSpPr>
+          <p:cNvPr id="4" name="Slide Number Placeholder 3"/>
+          <p:cNvSpPr>
+            <a:spLocks noGrp="1"/>
+          </p:cNvSpPr>
+          <p:nvPr>
+            <p:ph type="sldNum" idx="5"/>
+          </p:nvPr>
+        </p:nvSpPr>
+        <p:spPr/>
+        <p:txBody>
+          <a:bodyPr/>
+          <a:lstStyle/>
+          <a:p>
+            <a:endParaRPr/>
+          </a:p>
+        </p:txBody>
+      </p:sp>
+    </p:spTree>
+  </p:cSld>
+  <p:clrMapOvr>
+    <a:masterClrMapping/>
+  </p:clrMapOvr>
+</p:notes>
+</file>
+
 <file path=ppt/slideLayouts/slideLayout1.xml><?xml version="1.0" encoding="utf-8"?>
 <p:sldLayout xmlns:a="http://schemas.openxmlformats.org/drawingml/2006/main" xmlns:r="http://schemas.openxmlformats.org/officeDocument/2006/relationships" xmlns:p="http://schemas.openxmlformats.org/presentationml/2006/main" type="title" preserve="1">
   <p:cSld name="タイトル スライド">
@@ -158,12 +826,12 @@
           <a:bodyPr anchor="b"/>
           <a:lstStyle>
             <a:lvl1pPr algn="ctr">
+              <a:buNone/>
               <a:defRPr sz="6000"/>
             </a:lvl1pPr>
           </a:lstStyle>
           <a:p>
             <a:r>
-              <a:rPr kumimoji="1" lang="ja-JP" altLang="en-US"/>
               <a:t>マスター タイトルの書式設定</a:t>
             </a:r>
           </a:p>
@@ -233,7 +901,6 @@
           </a:lstStyle>
           <a:p>
             <a:r>
-              <a:rPr kumimoji="1" lang="ja-JP" altLang="en-US"/>
               <a:t>マスター サブタイトルの書式設定</a:t>
             </a:r>
           </a:p>
@@ -252,7 +919,7 @@
             <a:spLocks noGrp="1"/>
           </p:cNvSpPr>
           <p:nvPr>
-            <p:ph type="dt" sz="half" idx="10"/>
+            <p:ph type="dt" idx="10"/>
           </p:nvPr>
         </p:nvSpPr>
         <p:spPr/>
@@ -261,10 +928,9 @@
           <a:lstStyle/>
           <a:p>
             <a:fld id="{3758AE5C-1802-44DF-8FF7-B9F28567BF0D}" type="datetimeFigureOut">
-              <a:rPr kumimoji="1" lang="ja-JP" altLang="en-US" smtClean="0"/>
-              <a:t>2026/7/18</a:t>
+              <a:t>2026/8/5</a:t>
             </a:fld>
-            <a:endParaRPr kumimoji="1" lang="ja-JP" altLang="en-US"/>
+            <a:endParaRPr/>
           </a:p>
         </p:txBody>
       </p:sp>
@@ -281,7 +947,7 @@
             <a:spLocks noGrp="1"/>
           </p:cNvSpPr>
           <p:nvPr>
-            <p:ph type="ftr" sz="quarter" idx="11"/>
+            <p:ph type="ftr" idx="11"/>
           </p:nvPr>
         </p:nvSpPr>
         <p:spPr/>
@@ -289,7 +955,7 @@
           <a:bodyPr/>
           <a:lstStyle/>
           <a:p>
-            <a:endParaRPr kumimoji="1" lang="ja-JP" altLang="en-US"/>
+            <a:endParaRPr/>
           </a:p>
         </p:txBody>
       </p:sp>
@@ -306,7 +972,7 @@
             <a:spLocks noGrp="1"/>
           </p:cNvSpPr>
           <p:nvPr>
-            <p:ph type="sldNum" sz="quarter" idx="12"/>
+            <p:ph type="sldNum" idx="12"/>
           </p:nvPr>
         </p:nvSpPr>
         <p:spPr/>
@@ -315,19 +981,13 @@
           <a:lstStyle/>
           <a:p>
             <a:fld id="{87FE6054-7650-435E-A483-FED81FA94D0F}" type="slidenum">
-              <a:rPr kumimoji="1" lang="ja-JP" altLang="en-US" smtClean="0"/>
               <a:t>‹#›</a:t>
             </a:fld>
-            <a:endParaRPr kumimoji="1" lang="ja-JP" altLang="en-US"/>
+            <a:endParaRPr/>
           </a:p>
         </p:txBody>
       </p:sp>
     </p:spTree>
-    <p:extLst>
-      <p:ext uri="{BB962C8B-B14F-4D97-AF65-F5344CB8AC3E}">
-        <p14:creationId xmlns:p14="http://schemas.microsoft.com/office/powerpoint/2010/main" val="3594485643"/>
-      </p:ext>
-    </p:extLst>
   </p:cSld>
   <p:clrMapOvr>
     <a:masterClrMapping/>
@@ -374,7 +1034,6 @@
           <a:lstStyle/>
           <a:p>
             <a:r>
-              <a:rPr kumimoji="1" lang="ja-JP" altLang="en-US"/>
               <a:t>マスター タイトルの書式設定</a:t>
             </a:r>
           </a:p>
@@ -393,7 +1052,7 @@
             <a:spLocks noGrp="1"/>
           </p:cNvSpPr>
           <p:nvPr>
-            <p:ph type="body" orient="vert" idx="1"/>
+            <p:ph type="body" idx="1"/>
           </p:nvPr>
         </p:nvSpPr>
         <p:spPr/>
@@ -401,70 +1060,43 @@
           <a:bodyPr vert="eaVert"/>
           <a:lstStyle/>
           <a:p>
-            <a:pPr lvl="0"/>
-            <a:r>
-              <a:rPr kumimoji="1" lang="ja-JP" altLang="en-US"/>
+            <a:pPr lvl="0">
+              <a:buNone/>
+            </a:pPr>
+            <a:r>
               <a:t>マスター テキストの書式設定</a:t>
             </a:r>
           </a:p>
           <a:p>
-            <a:pPr lvl="1"/>
-            <a:r>
-              <a:rPr kumimoji="1" lang="ja-JP" altLang="en-US"/>
-              <a:t>第 </a:t>
-            </a:r>
-            <a:r>
-              <a:rPr kumimoji="1" lang="en-US" altLang="ja-JP"/>
-              <a:t>2 </a:t>
-            </a:r>
-            <a:r>
-              <a:rPr kumimoji="1" lang="ja-JP" altLang="en-US"/>
-              <a:t>レベル</a:t>
-            </a:r>
-          </a:p>
-          <a:p>
-            <a:pPr lvl="2"/>
-            <a:r>
-              <a:rPr kumimoji="1" lang="ja-JP" altLang="en-US"/>
-              <a:t>第 </a:t>
-            </a:r>
-            <a:r>
-              <a:rPr kumimoji="1" lang="en-US" altLang="ja-JP"/>
-              <a:t>3 </a:t>
-            </a:r>
-            <a:r>
-              <a:rPr kumimoji="1" lang="ja-JP" altLang="en-US"/>
-              <a:t>レベル</a:t>
-            </a:r>
-          </a:p>
-          <a:p>
-            <a:pPr lvl="3"/>
-            <a:r>
-              <a:rPr kumimoji="1" lang="ja-JP" altLang="en-US"/>
-              <a:t>第 </a:t>
-            </a:r>
-            <a:r>
-              <a:rPr kumimoji="1" lang="en-US" altLang="ja-JP"/>
-              <a:t>4 </a:t>
-            </a:r>
-            <a:r>
-              <a:rPr kumimoji="1" lang="ja-JP" altLang="en-US"/>
-              <a:t>レベル</a:t>
-            </a:r>
-          </a:p>
-          <a:p>
-            <a:pPr lvl="4"/>
-            <a:r>
-              <a:rPr kumimoji="1" lang="ja-JP" altLang="en-US"/>
-              <a:t>第 </a:t>
-            </a:r>
-            <a:r>
-              <a:rPr kumimoji="1" lang="en-US" altLang="ja-JP"/>
-              <a:t>5 </a:t>
-            </a:r>
-            <a:r>
-              <a:rPr kumimoji="1" lang="ja-JP" altLang="en-US"/>
-              <a:t>レベル</a:t>
+            <a:pPr lvl="1">
+              <a:buNone/>
+            </a:pPr>
+            <a:r>
+              <a:t>第 2 レベル</a:t>
+            </a:r>
+          </a:p>
+          <a:p>
+            <a:pPr lvl="2">
+              <a:buNone/>
+            </a:pPr>
+            <a:r>
+              <a:t>第 3 レベル</a:t>
+            </a:r>
+          </a:p>
+          <a:p>
+            <a:pPr lvl="3">
+              <a:buNone/>
+            </a:pPr>
+            <a:r>
+              <a:t>第 4 レベル</a:t>
+            </a:r>
+          </a:p>
+          <a:p>
+            <a:pPr lvl="4">
+              <a:buNone/>
+            </a:pPr>
+            <a:r>
+              <a:t>第 5 レベル</a:t>
             </a:r>
           </a:p>
         </p:txBody>
@@ -482,7 +1114,7 @@
             <a:spLocks noGrp="1"/>
           </p:cNvSpPr>
           <p:nvPr>
-            <p:ph type="dt" sz="half" idx="10"/>
+            <p:ph type="dt" idx="10"/>
           </p:nvPr>
         </p:nvSpPr>
         <p:spPr/>
@@ -491,10 +1123,9 @@
           <a:lstStyle/>
           <a:p>
             <a:fld id="{3758AE5C-1802-44DF-8FF7-B9F28567BF0D}" type="datetimeFigureOut">
-              <a:rPr kumimoji="1" lang="ja-JP" altLang="en-US" smtClean="0"/>
-              <a:t>2026/7/18</a:t>
+              <a:t>2026/8/5</a:t>
             </a:fld>
-            <a:endParaRPr kumimoji="1" lang="ja-JP" altLang="en-US"/>
+            <a:endParaRPr/>
           </a:p>
         </p:txBody>
       </p:sp>
@@ -511,7 +1142,7 @@
             <a:spLocks noGrp="1"/>
           </p:cNvSpPr>
           <p:nvPr>
-            <p:ph type="ftr" sz="quarter" idx="11"/>
+            <p:ph type="ftr" idx="11"/>
           </p:nvPr>
         </p:nvSpPr>
         <p:spPr/>
@@ -519,7 +1150,7 @@
           <a:bodyPr/>
           <a:lstStyle/>
           <a:p>
-            <a:endParaRPr kumimoji="1" lang="ja-JP" altLang="en-US"/>
+            <a:endParaRPr/>
           </a:p>
         </p:txBody>
       </p:sp>
@@ -536,7 +1167,7 @@
             <a:spLocks noGrp="1"/>
           </p:cNvSpPr>
           <p:nvPr>
-            <p:ph type="sldNum" sz="quarter" idx="12"/>
+            <p:ph type="sldNum" idx="12"/>
           </p:nvPr>
         </p:nvSpPr>
         <p:spPr/>
@@ -545,19 +1176,13 @@
           <a:lstStyle/>
           <a:p>
             <a:fld id="{87FE6054-7650-435E-A483-FED81FA94D0F}" type="slidenum">
-              <a:rPr kumimoji="1" lang="ja-JP" altLang="en-US" smtClean="0"/>
               <a:t>‹#›</a:t>
             </a:fld>
-            <a:endParaRPr kumimoji="1" lang="ja-JP" altLang="en-US"/>
+            <a:endParaRPr/>
           </a:p>
         </p:txBody>
       </p:sp>
     </p:spTree>
-    <p:extLst>
-      <p:ext uri="{BB962C8B-B14F-4D97-AF65-F5344CB8AC3E}">
-        <p14:creationId xmlns:p14="http://schemas.microsoft.com/office/powerpoint/2010/main" val="1139206417"/>
-      </p:ext>
-    </p:extLst>
   </p:cSld>
   <p:clrMapOvr>
     <a:masterClrMapping/>
@@ -595,7 +1220,7 @@
             <a:spLocks noGrp="1"/>
           </p:cNvSpPr>
           <p:nvPr>
-            <p:ph type="title" orient="vert"/>
+            <p:ph type="title"/>
           </p:nvPr>
         </p:nvSpPr>
         <p:spPr>
@@ -609,7 +1234,6 @@
           <a:lstStyle/>
           <a:p>
             <a:r>
-              <a:rPr kumimoji="1" lang="ja-JP" altLang="en-US"/>
               <a:t>マスター タイトルの書式設定</a:t>
             </a:r>
           </a:p>
@@ -628,7 +1252,7 @@
             <a:spLocks noGrp="1"/>
           </p:cNvSpPr>
           <p:nvPr>
-            <p:ph type="body" orient="vert" idx="1"/>
+            <p:ph type="body" idx="1"/>
           </p:nvPr>
         </p:nvSpPr>
         <p:spPr>
@@ -641,70 +1265,43 @@
           <a:bodyPr vert="eaVert"/>
           <a:lstStyle/>
           <a:p>
-            <a:pPr lvl="0"/>
-            <a:r>
-              <a:rPr kumimoji="1" lang="ja-JP" altLang="en-US"/>
+            <a:pPr lvl="0">
+              <a:buNone/>
+            </a:pPr>
+            <a:r>
               <a:t>マスター テキストの書式設定</a:t>
             </a:r>
           </a:p>
           <a:p>
-            <a:pPr lvl="1"/>
-            <a:r>
-              <a:rPr kumimoji="1" lang="ja-JP" altLang="en-US"/>
-              <a:t>第 </a:t>
-            </a:r>
-            <a:r>
-              <a:rPr kumimoji="1" lang="en-US" altLang="ja-JP"/>
-              <a:t>2 </a:t>
-            </a:r>
-            <a:r>
-              <a:rPr kumimoji="1" lang="ja-JP" altLang="en-US"/>
-              <a:t>レベル</a:t>
-            </a:r>
-          </a:p>
-          <a:p>
-            <a:pPr lvl="2"/>
-            <a:r>
-              <a:rPr kumimoji="1" lang="ja-JP" altLang="en-US"/>
-              <a:t>第 </a:t>
-            </a:r>
-            <a:r>
-              <a:rPr kumimoji="1" lang="en-US" altLang="ja-JP"/>
-              <a:t>3 </a:t>
-            </a:r>
-            <a:r>
-              <a:rPr kumimoji="1" lang="ja-JP" altLang="en-US"/>
-              <a:t>レベル</a:t>
-            </a:r>
-          </a:p>
-          <a:p>
-            <a:pPr lvl="3"/>
-            <a:r>
-              <a:rPr kumimoji="1" lang="ja-JP" altLang="en-US"/>
-              <a:t>第 </a:t>
-            </a:r>
-            <a:r>
-              <a:rPr kumimoji="1" lang="en-US" altLang="ja-JP"/>
-              <a:t>4 </a:t>
-            </a:r>
-            <a:r>
-              <a:rPr kumimoji="1" lang="ja-JP" altLang="en-US"/>
-              <a:t>レベル</a:t>
-            </a:r>
-          </a:p>
-          <a:p>
-            <a:pPr lvl="4"/>
-            <a:r>
-              <a:rPr kumimoji="1" lang="ja-JP" altLang="en-US"/>
-              <a:t>第 </a:t>
-            </a:r>
-            <a:r>
-              <a:rPr kumimoji="1" lang="en-US" altLang="ja-JP"/>
-              <a:t>5 </a:t>
-            </a:r>
-            <a:r>
-              <a:rPr kumimoji="1" lang="ja-JP" altLang="en-US"/>
-              <a:t>レベル</a:t>
+            <a:pPr lvl="1">
+              <a:buNone/>
+            </a:pPr>
+            <a:r>
+              <a:t>第 2 レベル</a:t>
+            </a:r>
+          </a:p>
+          <a:p>
+            <a:pPr lvl="2">
+              <a:buNone/>
+            </a:pPr>
+            <a:r>
+              <a:t>第 3 レベル</a:t>
+            </a:r>
+          </a:p>
+          <a:p>
+            <a:pPr lvl="3">
+              <a:buNone/>
+            </a:pPr>
+            <a:r>
+              <a:t>第 4 レベル</a:t>
+            </a:r>
+          </a:p>
+          <a:p>
+            <a:pPr lvl="4">
+              <a:buNone/>
+            </a:pPr>
+            <a:r>
+              <a:t>第 5 レベル</a:t>
             </a:r>
           </a:p>
         </p:txBody>
@@ -722,7 +1319,7 @@
             <a:spLocks noGrp="1"/>
           </p:cNvSpPr>
           <p:nvPr>
-            <p:ph type="dt" sz="half" idx="10"/>
+            <p:ph type="dt" idx="10"/>
           </p:nvPr>
         </p:nvSpPr>
         <p:spPr/>
@@ -731,10 +1328,9 @@
           <a:lstStyle/>
           <a:p>
             <a:fld id="{3758AE5C-1802-44DF-8FF7-B9F28567BF0D}" type="datetimeFigureOut">
-              <a:rPr kumimoji="1" lang="ja-JP" altLang="en-US" smtClean="0"/>
-              <a:t>2026/7/18</a:t>
+              <a:t>2026/8/5</a:t>
             </a:fld>
-            <a:endParaRPr kumimoji="1" lang="ja-JP" altLang="en-US"/>
+            <a:endParaRPr/>
           </a:p>
         </p:txBody>
       </p:sp>
@@ -751,7 +1347,7 @@
             <a:spLocks noGrp="1"/>
           </p:cNvSpPr>
           <p:nvPr>
-            <p:ph type="ftr" sz="quarter" idx="11"/>
+            <p:ph type="ftr" idx="11"/>
           </p:nvPr>
         </p:nvSpPr>
         <p:spPr/>
@@ -759,7 +1355,7 @@
           <a:bodyPr/>
           <a:lstStyle/>
           <a:p>
-            <a:endParaRPr kumimoji="1" lang="ja-JP" altLang="en-US"/>
+            <a:endParaRPr/>
           </a:p>
         </p:txBody>
       </p:sp>
@@ -776,7 +1372,7 @@
             <a:spLocks noGrp="1"/>
           </p:cNvSpPr>
           <p:nvPr>
-            <p:ph type="sldNum" sz="quarter" idx="12"/>
+            <p:ph type="sldNum" idx="12"/>
           </p:nvPr>
         </p:nvSpPr>
         <p:spPr/>
@@ -785,19 +1381,13 @@
           <a:lstStyle/>
           <a:p>
             <a:fld id="{87FE6054-7650-435E-A483-FED81FA94D0F}" type="slidenum">
-              <a:rPr kumimoji="1" lang="ja-JP" altLang="en-US" smtClean="0"/>
               <a:t>‹#›</a:t>
             </a:fld>
-            <a:endParaRPr kumimoji="1" lang="ja-JP" altLang="en-US"/>
+            <a:endParaRPr/>
           </a:p>
         </p:txBody>
       </p:sp>
     </p:spTree>
-    <p:extLst>
-      <p:ext uri="{BB962C8B-B14F-4D97-AF65-F5344CB8AC3E}">
-        <p14:creationId xmlns:p14="http://schemas.microsoft.com/office/powerpoint/2010/main" val="1263935101"/>
-      </p:ext>
-    </p:extLst>
   </p:cSld>
   <p:clrMapOvr>
     <a:masterClrMapping/>
@@ -844,7 +1434,6 @@
           <a:lstStyle/>
           <a:p>
             <a:r>
-              <a:rPr kumimoji="1" lang="ja-JP" altLang="en-US"/>
               <a:t>マスター タイトルの書式設定</a:t>
             </a:r>
           </a:p>
@@ -871,70 +1460,43 @@
           <a:bodyPr/>
           <a:lstStyle/>
           <a:p>
-            <a:pPr lvl="0"/>
-            <a:r>
-              <a:rPr kumimoji="1" lang="ja-JP" altLang="en-US"/>
+            <a:pPr lvl="0">
+              <a:buNone/>
+            </a:pPr>
+            <a:r>
               <a:t>マスター テキストの書式設定</a:t>
             </a:r>
           </a:p>
           <a:p>
-            <a:pPr lvl="1"/>
-            <a:r>
-              <a:rPr kumimoji="1" lang="ja-JP" altLang="en-US"/>
-              <a:t>第 </a:t>
-            </a:r>
-            <a:r>
-              <a:rPr kumimoji="1" lang="en-US" altLang="ja-JP"/>
-              <a:t>2 </a:t>
-            </a:r>
-            <a:r>
-              <a:rPr kumimoji="1" lang="ja-JP" altLang="en-US"/>
-              <a:t>レベル</a:t>
-            </a:r>
-          </a:p>
-          <a:p>
-            <a:pPr lvl="2"/>
-            <a:r>
-              <a:rPr kumimoji="1" lang="ja-JP" altLang="en-US"/>
-              <a:t>第 </a:t>
-            </a:r>
-            <a:r>
-              <a:rPr kumimoji="1" lang="en-US" altLang="ja-JP"/>
-              <a:t>3 </a:t>
-            </a:r>
-            <a:r>
-              <a:rPr kumimoji="1" lang="ja-JP" altLang="en-US"/>
-              <a:t>レベル</a:t>
-            </a:r>
-          </a:p>
-          <a:p>
-            <a:pPr lvl="3"/>
-            <a:r>
-              <a:rPr kumimoji="1" lang="ja-JP" altLang="en-US"/>
-              <a:t>第 </a:t>
-            </a:r>
-            <a:r>
-              <a:rPr kumimoji="1" lang="en-US" altLang="ja-JP"/>
-              <a:t>4 </a:t>
-            </a:r>
-            <a:r>
-              <a:rPr kumimoji="1" lang="ja-JP" altLang="en-US"/>
-              <a:t>レベル</a:t>
-            </a:r>
-          </a:p>
-          <a:p>
-            <a:pPr lvl="4"/>
-            <a:r>
-              <a:rPr kumimoji="1" lang="ja-JP" altLang="en-US"/>
-              <a:t>第 </a:t>
-            </a:r>
-            <a:r>
-              <a:rPr kumimoji="1" lang="en-US" altLang="ja-JP"/>
-              <a:t>5 </a:t>
-            </a:r>
-            <a:r>
-              <a:rPr kumimoji="1" lang="ja-JP" altLang="en-US"/>
-              <a:t>レベル</a:t>
+            <a:pPr lvl="1">
+              <a:buNone/>
+            </a:pPr>
+            <a:r>
+              <a:t>第 2 レベル</a:t>
+            </a:r>
+          </a:p>
+          <a:p>
+            <a:pPr lvl="2">
+              <a:buNone/>
+            </a:pPr>
+            <a:r>
+              <a:t>第 3 レベル</a:t>
+            </a:r>
+          </a:p>
+          <a:p>
+            <a:pPr lvl="3">
+              <a:buNone/>
+            </a:pPr>
+            <a:r>
+              <a:t>第 4 レベル</a:t>
+            </a:r>
+          </a:p>
+          <a:p>
+            <a:pPr lvl="4">
+              <a:buNone/>
+            </a:pPr>
+            <a:r>
+              <a:t>第 5 レベル</a:t>
             </a:r>
           </a:p>
         </p:txBody>
@@ -952,7 +1514,7 @@
             <a:spLocks noGrp="1"/>
           </p:cNvSpPr>
           <p:nvPr>
-            <p:ph type="dt" sz="half" idx="10"/>
+            <p:ph type="dt" idx="10"/>
           </p:nvPr>
         </p:nvSpPr>
         <p:spPr/>
@@ -961,10 +1523,9 @@
           <a:lstStyle/>
           <a:p>
             <a:fld id="{3758AE5C-1802-44DF-8FF7-B9F28567BF0D}" type="datetimeFigureOut">
-              <a:rPr kumimoji="1" lang="ja-JP" altLang="en-US" smtClean="0"/>
-              <a:t>2026/7/18</a:t>
+              <a:t>2026/8/5</a:t>
             </a:fld>
-            <a:endParaRPr kumimoji="1" lang="ja-JP" altLang="en-US"/>
+            <a:endParaRPr/>
           </a:p>
         </p:txBody>
       </p:sp>
@@ -981,7 +1542,7 @@
             <a:spLocks noGrp="1"/>
           </p:cNvSpPr>
           <p:nvPr>
-            <p:ph type="ftr" sz="quarter" idx="11"/>
+            <p:ph type="ftr" idx="11"/>
           </p:nvPr>
         </p:nvSpPr>
         <p:spPr/>
@@ -989,7 +1550,7 @@
           <a:bodyPr/>
           <a:lstStyle/>
           <a:p>
-            <a:endParaRPr kumimoji="1" lang="ja-JP" altLang="en-US"/>
+            <a:endParaRPr/>
           </a:p>
         </p:txBody>
       </p:sp>
@@ -1006,7 +1567,7 @@
             <a:spLocks noGrp="1"/>
           </p:cNvSpPr>
           <p:nvPr>
-            <p:ph type="sldNum" sz="quarter" idx="12"/>
+            <p:ph type="sldNum" idx="12"/>
           </p:nvPr>
         </p:nvSpPr>
         <p:spPr/>
@@ -1015,19 +1576,13 @@
           <a:lstStyle/>
           <a:p>
             <a:fld id="{87FE6054-7650-435E-A483-FED81FA94D0F}" type="slidenum">
-              <a:rPr kumimoji="1" lang="ja-JP" altLang="en-US" smtClean="0"/>
               <a:t>‹#›</a:t>
             </a:fld>
-            <a:endParaRPr kumimoji="1" lang="ja-JP" altLang="en-US"/>
+            <a:endParaRPr/>
           </a:p>
         </p:txBody>
       </p:sp>
     </p:spTree>
-    <p:extLst>
-      <p:ext uri="{BB962C8B-B14F-4D97-AF65-F5344CB8AC3E}">
-        <p14:creationId xmlns:p14="http://schemas.microsoft.com/office/powerpoint/2010/main" val="2768909183"/>
-      </p:ext>
-    </p:extLst>
   </p:cSld>
   <p:clrMapOvr>
     <a:masterClrMapping/>
@@ -1078,12 +1633,12 @@
           <a:bodyPr anchor="b"/>
           <a:lstStyle>
             <a:lvl1pPr>
+              <a:buNone/>
               <a:defRPr sz="6000"/>
             </a:lvl1pPr>
           </a:lstStyle>
           <a:p>
             <a:r>
-              <a:rPr kumimoji="1" lang="ja-JP" altLang="en-US"/>
               <a:t>マスター タイトルの書式設定</a:t>
             </a:r>
           </a:p>
@@ -1206,9 +1761,10 @@
             </a:lvl9pPr>
           </a:lstStyle>
           <a:p>
-            <a:pPr lvl="0"/>
-            <a:r>
-              <a:rPr kumimoji="1" lang="ja-JP" altLang="en-US"/>
+            <a:pPr lvl="0">
+              <a:buNone/>
+            </a:pPr>
+            <a:r>
               <a:t>マスター テキストの書式設定</a:t>
             </a:r>
           </a:p>
@@ -1227,7 +1783,7 @@
             <a:spLocks noGrp="1"/>
           </p:cNvSpPr>
           <p:nvPr>
-            <p:ph type="dt" sz="half" idx="10"/>
+            <p:ph type="dt" idx="10"/>
           </p:nvPr>
         </p:nvSpPr>
         <p:spPr/>
@@ -1236,10 +1792,9 @@
           <a:lstStyle/>
           <a:p>
             <a:fld id="{3758AE5C-1802-44DF-8FF7-B9F28567BF0D}" type="datetimeFigureOut">
-              <a:rPr kumimoji="1" lang="ja-JP" altLang="en-US" smtClean="0"/>
-              <a:t>2026/7/18</a:t>
+              <a:t>2026/8/5</a:t>
             </a:fld>
-            <a:endParaRPr kumimoji="1" lang="ja-JP" altLang="en-US"/>
+            <a:endParaRPr/>
           </a:p>
         </p:txBody>
       </p:sp>
@@ -1256,7 +1811,7 @@
             <a:spLocks noGrp="1"/>
           </p:cNvSpPr>
           <p:nvPr>
-            <p:ph type="ftr" sz="quarter" idx="11"/>
+            <p:ph type="ftr" idx="11"/>
           </p:nvPr>
         </p:nvSpPr>
         <p:spPr/>
@@ -1264,7 +1819,7 @@
           <a:bodyPr/>
           <a:lstStyle/>
           <a:p>
-            <a:endParaRPr kumimoji="1" lang="ja-JP" altLang="en-US"/>
+            <a:endParaRPr/>
           </a:p>
         </p:txBody>
       </p:sp>
@@ -1281,7 +1836,7 @@
             <a:spLocks noGrp="1"/>
           </p:cNvSpPr>
           <p:nvPr>
-            <p:ph type="sldNum" sz="quarter" idx="12"/>
+            <p:ph type="sldNum" idx="12"/>
           </p:nvPr>
         </p:nvSpPr>
         <p:spPr/>
@@ -1290,19 +1845,13 @@
           <a:lstStyle/>
           <a:p>
             <a:fld id="{87FE6054-7650-435E-A483-FED81FA94D0F}" type="slidenum">
-              <a:rPr kumimoji="1" lang="ja-JP" altLang="en-US" smtClean="0"/>
               <a:t>‹#›</a:t>
             </a:fld>
-            <a:endParaRPr kumimoji="1" lang="ja-JP" altLang="en-US"/>
+            <a:endParaRPr/>
           </a:p>
         </p:txBody>
       </p:sp>
     </p:spTree>
-    <p:extLst>
-      <p:ext uri="{BB962C8B-B14F-4D97-AF65-F5344CB8AC3E}">
-        <p14:creationId xmlns:p14="http://schemas.microsoft.com/office/powerpoint/2010/main" val="2035490362"/>
-      </p:ext>
-    </p:extLst>
   </p:cSld>
   <p:clrMapOvr>
     <a:masterClrMapping/>
@@ -1349,7 +1898,6 @@
           <a:lstStyle/>
           <a:p>
             <a:r>
-              <a:rPr kumimoji="1" lang="ja-JP" altLang="en-US"/>
               <a:t>マスター タイトルの書式設定</a:t>
             </a:r>
           </a:p>
@@ -1368,7 +1916,7 @@
             <a:spLocks noGrp="1"/>
           </p:cNvSpPr>
           <p:nvPr>
-            <p:ph sz="half" idx="1"/>
+            <p:ph idx="1"/>
           </p:nvPr>
         </p:nvSpPr>
         <p:spPr>
@@ -1381,70 +1929,43 @@
           <a:bodyPr/>
           <a:lstStyle/>
           <a:p>
-            <a:pPr lvl="0"/>
-            <a:r>
-              <a:rPr kumimoji="1" lang="ja-JP" altLang="en-US"/>
+            <a:pPr lvl="0">
+              <a:buNone/>
+            </a:pPr>
+            <a:r>
               <a:t>マスター テキストの書式設定</a:t>
             </a:r>
           </a:p>
           <a:p>
-            <a:pPr lvl="1"/>
-            <a:r>
-              <a:rPr kumimoji="1" lang="ja-JP" altLang="en-US"/>
-              <a:t>第 </a:t>
-            </a:r>
-            <a:r>
-              <a:rPr kumimoji="1" lang="en-US" altLang="ja-JP"/>
-              <a:t>2 </a:t>
-            </a:r>
-            <a:r>
-              <a:rPr kumimoji="1" lang="ja-JP" altLang="en-US"/>
-              <a:t>レベル</a:t>
-            </a:r>
-          </a:p>
-          <a:p>
-            <a:pPr lvl="2"/>
-            <a:r>
-              <a:rPr kumimoji="1" lang="ja-JP" altLang="en-US"/>
-              <a:t>第 </a:t>
-            </a:r>
-            <a:r>
-              <a:rPr kumimoji="1" lang="en-US" altLang="ja-JP"/>
-              <a:t>3 </a:t>
-            </a:r>
-            <a:r>
-              <a:rPr kumimoji="1" lang="ja-JP" altLang="en-US"/>
-              <a:t>レベル</a:t>
-            </a:r>
-          </a:p>
-          <a:p>
-            <a:pPr lvl="3"/>
-            <a:r>
-              <a:rPr kumimoji="1" lang="ja-JP" altLang="en-US"/>
-              <a:t>第 </a:t>
-            </a:r>
-            <a:r>
-              <a:rPr kumimoji="1" lang="en-US" altLang="ja-JP"/>
-              <a:t>4 </a:t>
-            </a:r>
-            <a:r>
-              <a:rPr kumimoji="1" lang="ja-JP" altLang="en-US"/>
-              <a:t>レベル</a:t>
-            </a:r>
-          </a:p>
-          <a:p>
-            <a:pPr lvl="4"/>
-            <a:r>
-              <a:rPr kumimoji="1" lang="ja-JP" altLang="en-US"/>
-              <a:t>第 </a:t>
-            </a:r>
-            <a:r>
-              <a:rPr kumimoji="1" lang="en-US" altLang="ja-JP"/>
-              <a:t>5 </a:t>
-            </a:r>
-            <a:r>
-              <a:rPr kumimoji="1" lang="ja-JP" altLang="en-US"/>
-              <a:t>レベル</a:t>
+            <a:pPr lvl="1">
+              <a:buNone/>
+            </a:pPr>
+            <a:r>
+              <a:t>第 2 レベル</a:t>
+            </a:r>
+          </a:p>
+          <a:p>
+            <a:pPr lvl="2">
+              <a:buNone/>
+            </a:pPr>
+            <a:r>
+              <a:t>第 3 レベル</a:t>
+            </a:r>
+          </a:p>
+          <a:p>
+            <a:pPr lvl="3">
+              <a:buNone/>
+            </a:pPr>
+            <a:r>
+              <a:t>第 4 レベル</a:t>
+            </a:r>
+          </a:p>
+          <a:p>
+            <a:pPr lvl="4">
+              <a:buNone/>
+            </a:pPr>
+            <a:r>
+              <a:t>第 5 レベル</a:t>
             </a:r>
           </a:p>
         </p:txBody>
@@ -1462,7 +1983,7 @@
             <a:spLocks noGrp="1"/>
           </p:cNvSpPr>
           <p:nvPr>
-            <p:ph sz="half" idx="2"/>
+            <p:ph idx="2"/>
           </p:nvPr>
         </p:nvSpPr>
         <p:spPr>
@@ -1475,70 +1996,43 @@
           <a:bodyPr/>
           <a:lstStyle/>
           <a:p>
-            <a:pPr lvl="0"/>
-            <a:r>
-              <a:rPr kumimoji="1" lang="ja-JP" altLang="en-US"/>
+            <a:pPr lvl="0">
+              <a:buNone/>
+            </a:pPr>
+            <a:r>
               <a:t>マスター テキストの書式設定</a:t>
             </a:r>
           </a:p>
           <a:p>
-            <a:pPr lvl="1"/>
-            <a:r>
-              <a:rPr kumimoji="1" lang="ja-JP" altLang="en-US"/>
-              <a:t>第 </a:t>
-            </a:r>
-            <a:r>
-              <a:rPr kumimoji="1" lang="en-US" altLang="ja-JP"/>
-              <a:t>2 </a:t>
-            </a:r>
-            <a:r>
-              <a:rPr kumimoji="1" lang="ja-JP" altLang="en-US"/>
-              <a:t>レベル</a:t>
-            </a:r>
-          </a:p>
-          <a:p>
-            <a:pPr lvl="2"/>
-            <a:r>
-              <a:rPr kumimoji="1" lang="ja-JP" altLang="en-US"/>
-              <a:t>第 </a:t>
-            </a:r>
-            <a:r>
-              <a:rPr kumimoji="1" lang="en-US" altLang="ja-JP"/>
-              <a:t>3 </a:t>
-            </a:r>
-            <a:r>
-              <a:rPr kumimoji="1" lang="ja-JP" altLang="en-US"/>
-              <a:t>レベル</a:t>
-            </a:r>
-          </a:p>
-          <a:p>
-            <a:pPr lvl="3"/>
-            <a:r>
-              <a:rPr kumimoji="1" lang="ja-JP" altLang="en-US"/>
-              <a:t>第 </a:t>
-            </a:r>
-            <a:r>
-              <a:rPr kumimoji="1" lang="en-US" altLang="ja-JP"/>
-              <a:t>4 </a:t>
-            </a:r>
-            <a:r>
-              <a:rPr kumimoji="1" lang="ja-JP" altLang="en-US"/>
-              <a:t>レベル</a:t>
-            </a:r>
-          </a:p>
-          <a:p>
-            <a:pPr lvl="4"/>
-            <a:r>
-              <a:rPr kumimoji="1" lang="ja-JP" altLang="en-US"/>
-              <a:t>第 </a:t>
-            </a:r>
-            <a:r>
-              <a:rPr kumimoji="1" lang="en-US" altLang="ja-JP"/>
-              <a:t>5 </a:t>
-            </a:r>
-            <a:r>
-              <a:rPr kumimoji="1" lang="ja-JP" altLang="en-US"/>
-              <a:t>レベル</a:t>
+            <a:pPr lvl="1">
+              <a:buNone/>
+            </a:pPr>
+            <a:r>
+              <a:t>第 2 レベル</a:t>
+            </a:r>
+          </a:p>
+          <a:p>
+            <a:pPr lvl="2">
+              <a:buNone/>
+            </a:pPr>
+            <a:r>
+              <a:t>第 3 レベル</a:t>
+            </a:r>
+          </a:p>
+          <a:p>
+            <a:pPr lvl="3">
+              <a:buNone/>
+            </a:pPr>
+            <a:r>
+              <a:t>第 4 レベル</a:t>
+            </a:r>
+          </a:p>
+          <a:p>
+            <a:pPr lvl="4">
+              <a:buNone/>
+            </a:pPr>
+            <a:r>
+              <a:t>第 5 レベル</a:t>
             </a:r>
           </a:p>
         </p:txBody>
@@ -1556,7 +2050,7 @@
             <a:spLocks noGrp="1"/>
           </p:cNvSpPr>
           <p:nvPr>
-            <p:ph type="dt" sz="half" idx="10"/>
+            <p:ph type="dt" idx="10"/>
           </p:nvPr>
         </p:nvSpPr>
         <p:spPr/>
@@ -1565,10 +2059,9 @@
           <a:lstStyle/>
           <a:p>
             <a:fld id="{3758AE5C-1802-44DF-8FF7-B9F28567BF0D}" type="datetimeFigureOut">
-              <a:rPr kumimoji="1" lang="ja-JP" altLang="en-US" smtClean="0"/>
-              <a:t>2026/7/18</a:t>
+              <a:t>2026/8/5</a:t>
             </a:fld>
-            <a:endParaRPr kumimoji="1" lang="ja-JP" altLang="en-US"/>
+            <a:endParaRPr/>
           </a:p>
         </p:txBody>
       </p:sp>
@@ -1585,7 +2078,7 @@
             <a:spLocks noGrp="1"/>
           </p:cNvSpPr>
           <p:nvPr>
-            <p:ph type="ftr" sz="quarter" idx="11"/>
+            <p:ph type="ftr" idx="11"/>
           </p:nvPr>
         </p:nvSpPr>
         <p:spPr/>
@@ -1593,7 +2086,7 @@
           <a:bodyPr/>
           <a:lstStyle/>
           <a:p>
-            <a:endParaRPr kumimoji="1" lang="ja-JP" altLang="en-US"/>
+            <a:endParaRPr/>
           </a:p>
         </p:txBody>
       </p:sp>
@@ -1610,7 +2103,7 @@
             <a:spLocks noGrp="1"/>
           </p:cNvSpPr>
           <p:nvPr>
-            <p:ph type="sldNum" sz="quarter" idx="12"/>
+            <p:ph type="sldNum" idx="12"/>
           </p:nvPr>
         </p:nvSpPr>
         <p:spPr/>
@@ -1619,19 +2112,13 @@
           <a:lstStyle/>
           <a:p>
             <a:fld id="{87FE6054-7650-435E-A483-FED81FA94D0F}" type="slidenum">
-              <a:rPr kumimoji="1" lang="ja-JP" altLang="en-US" smtClean="0"/>
               <a:t>‹#›</a:t>
             </a:fld>
-            <a:endParaRPr kumimoji="1" lang="ja-JP" altLang="en-US"/>
+            <a:endParaRPr/>
           </a:p>
         </p:txBody>
       </p:sp>
     </p:spTree>
-    <p:extLst>
-      <p:ext uri="{BB962C8B-B14F-4D97-AF65-F5344CB8AC3E}">
-        <p14:creationId xmlns:p14="http://schemas.microsoft.com/office/powerpoint/2010/main" val="2392054875"/>
-      </p:ext>
-    </p:extLst>
   </p:cSld>
   <p:clrMapOvr>
     <a:masterClrMapping/>
@@ -1683,7 +2170,6 @@
           <a:lstStyle/>
           <a:p>
             <a:r>
-              <a:rPr kumimoji="1" lang="ja-JP" altLang="en-US"/>
               <a:t>マスター タイトルの書式設定</a:t>
             </a:r>
           </a:p>
@@ -1752,9 +2238,10 @@
             </a:lvl9pPr>
           </a:lstStyle>
           <a:p>
-            <a:pPr lvl="0"/>
-            <a:r>
-              <a:rPr kumimoji="1" lang="ja-JP" altLang="en-US"/>
+            <a:pPr lvl="0">
+              <a:buNone/>
+            </a:pPr>
+            <a:r>
               <a:t>マスター テキストの書式設定</a:t>
             </a:r>
           </a:p>
@@ -1773,7 +2260,7 @@
             <a:spLocks noGrp="1"/>
           </p:cNvSpPr>
           <p:nvPr>
-            <p:ph sz="half" idx="2"/>
+            <p:ph idx="2"/>
           </p:nvPr>
         </p:nvSpPr>
         <p:spPr>
@@ -1786,70 +2273,43 @@
           <a:bodyPr/>
           <a:lstStyle/>
           <a:p>
-            <a:pPr lvl="0"/>
-            <a:r>
-              <a:rPr kumimoji="1" lang="ja-JP" altLang="en-US"/>
+            <a:pPr lvl="0">
+              <a:buNone/>
+            </a:pPr>
+            <a:r>
               <a:t>マスター テキストの書式設定</a:t>
             </a:r>
           </a:p>
           <a:p>
-            <a:pPr lvl="1"/>
-            <a:r>
-              <a:rPr kumimoji="1" lang="ja-JP" altLang="en-US"/>
-              <a:t>第 </a:t>
-            </a:r>
-            <a:r>
-              <a:rPr kumimoji="1" lang="en-US" altLang="ja-JP"/>
-              <a:t>2 </a:t>
-            </a:r>
-            <a:r>
-              <a:rPr kumimoji="1" lang="ja-JP" altLang="en-US"/>
-              <a:t>レベル</a:t>
-            </a:r>
-          </a:p>
-          <a:p>
-            <a:pPr lvl="2"/>
-            <a:r>
-              <a:rPr kumimoji="1" lang="ja-JP" altLang="en-US"/>
-              <a:t>第 </a:t>
-            </a:r>
-            <a:r>
-              <a:rPr kumimoji="1" lang="en-US" altLang="ja-JP"/>
-              <a:t>3 </a:t>
-            </a:r>
-            <a:r>
-              <a:rPr kumimoji="1" lang="ja-JP" altLang="en-US"/>
-              <a:t>レベル</a:t>
-            </a:r>
-          </a:p>
-          <a:p>
-            <a:pPr lvl="3"/>
-            <a:r>
-              <a:rPr kumimoji="1" lang="ja-JP" altLang="en-US"/>
-              <a:t>第 </a:t>
-            </a:r>
-            <a:r>
-              <a:rPr kumimoji="1" lang="en-US" altLang="ja-JP"/>
-              <a:t>4 </a:t>
-            </a:r>
-            <a:r>
-              <a:rPr kumimoji="1" lang="ja-JP" altLang="en-US"/>
-              <a:t>レベル</a:t>
-            </a:r>
-          </a:p>
-          <a:p>
-            <a:pPr lvl="4"/>
-            <a:r>
-              <a:rPr kumimoji="1" lang="ja-JP" altLang="en-US"/>
-              <a:t>第 </a:t>
-            </a:r>
-            <a:r>
-              <a:rPr kumimoji="1" lang="en-US" altLang="ja-JP"/>
-              <a:t>5 </a:t>
-            </a:r>
-            <a:r>
-              <a:rPr kumimoji="1" lang="ja-JP" altLang="en-US"/>
-              <a:t>レベル</a:t>
+            <a:pPr lvl="1">
+              <a:buNone/>
+            </a:pPr>
+            <a:r>
+              <a:t>第 2 レベル</a:t>
+            </a:r>
+          </a:p>
+          <a:p>
+            <a:pPr lvl="2">
+              <a:buNone/>
+            </a:pPr>
+            <a:r>
+              <a:t>第 3 レベル</a:t>
+            </a:r>
+          </a:p>
+          <a:p>
+            <a:pPr lvl="3">
+              <a:buNone/>
+            </a:pPr>
+            <a:r>
+              <a:t>第 4 レベル</a:t>
+            </a:r>
+          </a:p>
+          <a:p>
+            <a:pPr lvl="4">
+              <a:buNone/>
+            </a:pPr>
+            <a:r>
+              <a:t>第 5 レベル</a:t>
             </a:r>
           </a:p>
         </p:txBody>
@@ -1867,7 +2327,7 @@
             <a:spLocks noGrp="1"/>
           </p:cNvSpPr>
           <p:nvPr>
-            <p:ph type="body" sz="quarter" idx="3"/>
+            <p:ph type="body" idx="3"/>
           </p:nvPr>
         </p:nvSpPr>
         <p:spPr>
@@ -1917,9 +2377,10 @@
             </a:lvl9pPr>
           </a:lstStyle>
           <a:p>
-            <a:pPr lvl="0"/>
-            <a:r>
-              <a:rPr kumimoji="1" lang="ja-JP" altLang="en-US"/>
+            <a:pPr lvl="0">
+              <a:buNone/>
+            </a:pPr>
+            <a:r>
               <a:t>マスター テキストの書式設定</a:t>
             </a:r>
           </a:p>
@@ -1938,7 +2399,7 @@
             <a:spLocks noGrp="1"/>
           </p:cNvSpPr>
           <p:nvPr>
-            <p:ph sz="quarter" idx="4"/>
+            <p:ph idx="4"/>
           </p:nvPr>
         </p:nvSpPr>
         <p:spPr>
@@ -1951,70 +2412,43 @@
           <a:bodyPr/>
           <a:lstStyle/>
           <a:p>
-            <a:pPr lvl="0"/>
-            <a:r>
-              <a:rPr kumimoji="1" lang="ja-JP" altLang="en-US"/>
+            <a:pPr lvl="0">
+              <a:buNone/>
+            </a:pPr>
+            <a:r>
               <a:t>マスター テキストの書式設定</a:t>
             </a:r>
           </a:p>
           <a:p>
-            <a:pPr lvl="1"/>
-            <a:r>
-              <a:rPr kumimoji="1" lang="ja-JP" altLang="en-US"/>
-              <a:t>第 </a:t>
-            </a:r>
-            <a:r>
-              <a:rPr kumimoji="1" lang="en-US" altLang="ja-JP"/>
-              <a:t>2 </a:t>
-            </a:r>
-            <a:r>
-              <a:rPr kumimoji="1" lang="ja-JP" altLang="en-US"/>
-              <a:t>レベル</a:t>
-            </a:r>
-          </a:p>
-          <a:p>
-            <a:pPr lvl="2"/>
-            <a:r>
-              <a:rPr kumimoji="1" lang="ja-JP" altLang="en-US"/>
-              <a:t>第 </a:t>
-            </a:r>
-            <a:r>
-              <a:rPr kumimoji="1" lang="en-US" altLang="ja-JP"/>
-              <a:t>3 </a:t>
-            </a:r>
-            <a:r>
-              <a:rPr kumimoji="1" lang="ja-JP" altLang="en-US"/>
-              <a:t>レベル</a:t>
-            </a:r>
-          </a:p>
-          <a:p>
-            <a:pPr lvl="3"/>
-            <a:r>
-              <a:rPr kumimoji="1" lang="ja-JP" altLang="en-US"/>
-              <a:t>第 </a:t>
-            </a:r>
-            <a:r>
-              <a:rPr kumimoji="1" lang="en-US" altLang="ja-JP"/>
-              <a:t>4 </a:t>
-            </a:r>
-            <a:r>
-              <a:rPr kumimoji="1" lang="ja-JP" altLang="en-US"/>
-              <a:t>レベル</a:t>
-            </a:r>
-          </a:p>
-          <a:p>
-            <a:pPr lvl="4"/>
-            <a:r>
-              <a:rPr kumimoji="1" lang="ja-JP" altLang="en-US"/>
-              <a:t>第 </a:t>
-            </a:r>
-            <a:r>
-              <a:rPr kumimoji="1" lang="en-US" altLang="ja-JP"/>
-              <a:t>5 </a:t>
-            </a:r>
-            <a:r>
-              <a:rPr kumimoji="1" lang="ja-JP" altLang="en-US"/>
-              <a:t>レベル</a:t>
+            <a:pPr lvl="1">
+              <a:buNone/>
+            </a:pPr>
+            <a:r>
+              <a:t>第 2 レベル</a:t>
+            </a:r>
+          </a:p>
+          <a:p>
+            <a:pPr lvl="2">
+              <a:buNone/>
+            </a:pPr>
+            <a:r>
+              <a:t>第 3 レベル</a:t>
+            </a:r>
+          </a:p>
+          <a:p>
+            <a:pPr lvl="3">
+              <a:buNone/>
+            </a:pPr>
+            <a:r>
+              <a:t>第 4 レベル</a:t>
+            </a:r>
+          </a:p>
+          <a:p>
+            <a:pPr lvl="4">
+              <a:buNone/>
+            </a:pPr>
+            <a:r>
+              <a:t>第 5 レベル</a:t>
             </a:r>
           </a:p>
         </p:txBody>
@@ -2032,7 +2466,7 @@
             <a:spLocks noGrp="1"/>
           </p:cNvSpPr>
           <p:nvPr>
-            <p:ph type="dt" sz="half" idx="10"/>
+            <p:ph type="dt" idx="10"/>
           </p:nvPr>
         </p:nvSpPr>
         <p:spPr/>
@@ -2041,10 +2475,9 @@
           <a:lstStyle/>
           <a:p>
             <a:fld id="{3758AE5C-1802-44DF-8FF7-B9F28567BF0D}" type="datetimeFigureOut">
-              <a:rPr kumimoji="1" lang="ja-JP" altLang="en-US" smtClean="0"/>
-              <a:t>2026/7/18</a:t>
+              <a:t>2026/8/5</a:t>
             </a:fld>
-            <a:endParaRPr kumimoji="1" lang="ja-JP" altLang="en-US"/>
+            <a:endParaRPr/>
           </a:p>
         </p:txBody>
       </p:sp>
@@ -2061,7 +2494,7 @@
             <a:spLocks noGrp="1"/>
           </p:cNvSpPr>
           <p:nvPr>
-            <p:ph type="ftr" sz="quarter" idx="11"/>
+            <p:ph type="ftr" idx="11"/>
           </p:nvPr>
         </p:nvSpPr>
         <p:spPr/>
@@ -2069,7 +2502,7 @@
           <a:bodyPr/>
           <a:lstStyle/>
           <a:p>
-            <a:endParaRPr kumimoji="1" lang="ja-JP" altLang="en-US"/>
+            <a:endParaRPr/>
           </a:p>
         </p:txBody>
       </p:sp>
@@ -2086,7 +2519,7 @@
             <a:spLocks noGrp="1"/>
           </p:cNvSpPr>
           <p:nvPr>
-            <p:ph type="sldNum" sz="quarter" idx="12"/>
+            <p:ph type="sldNum" idx="12"/>
           </p:nvPr>
         </p:nvSpPr>
         <p:spPr/>
@@ -2095,19 +2528,13 @@
           <a:lstStyle/>
           <a:p>
             <a:fld id="{87FE6054-7650-435E-A483-FED81FA94D0F}" type="slidenum">
-              <a:rPr kumimoji="1" lang="ja-JP" altLang="en-US" smtClean="0"/>
               <a:t>‹#›</a:t>
             </a:fld>
-            <a:endParaRPr kumimoji="1" lang="ja-JP" altLang="en-US"/>
+            <a:endParaRPr/>
           </a:p>
         </p:txBody>
       </p:sp>
     </p:spTree>
-    <p:extLst>
-      <p:ext uri="{BB962C8B-B14F-4D97-AF65-F5344CB8AC3E}">
-        <p14:creationId xmlns:p14="http://schemas.microsoft.com/office/powerpoint/2010/main" val="108998422"/>
-      </p:ext>
-    </p:extLst>
   </p:cSld>
   <p:clrMapOvr>
     <a:masterClrMapping/>
@@ -2154,7 +2581,6 @@
           <a:lstStyle/>
           <a:p>
             <a:r>
-              <a:rPr kumimoji="1" lang="ja-JP" altLang="en-US"/>
               <a:t>マスター タイトルの書式設定</a:t>
             </a:r>
           </a:p>
@@ -2173,7 +2599,7 @@
             <a:spLocks noGrp="1"/>
           </p:cNvSpPr>
           <p:nvPr>
-            <p:ph type="dt" sz="half" idx="10"/>
+            <p:ph type="dt" idx="10"/>
           </p:nvPr>
         </p:nvSpPr>
         <p:spPr/>
@@ -2182,10 +2608,9 @@
           <a:lstStyle/>
           <a:p>
             <a:fld id="{3758AE5C-1802-44DF-8FF7-B9F28567BF0D}" type="datetimeFigureOut">
-              <a:rPr kumimoji="1" lang="ja-JP" altLang="en-US" smtClean="0"/>
-              <a:t>2026/7/18</a:t>
+              <a:t>2026/8/5</a:t>
             </a:fld>
-            <a:endParaRPr kumimoji="1" lang="ja-JP" altLang="en-US"/>
+            <a:endParaRPr/>
           </a:p>
         </p:txBody>
       </p:sp>
@@ -2202,7 +2627,7 @@
             <a:spLocks noGrp="1"/>
           </p:cNvSpPr>
           <p:nvPr>
-            <p:ph type="ftr" sz="quarter" idx="11"/>
+            <p:ph type="ftr" idx="11"/>
           </p:nvPr>
         </p:nvSpPr>
         <p:spPr/>
@@ -2210,7 +2635,7 @@
           <a:bodyPr/>
           <a:lstStyle/>
           <a:p>
-            <a:endParaRPr kumimoji="1" lang="ja-JP" altLang="en-US"/>
+            <a:endParaRPr/>
           </a:p>
         </p:txBody>
       </p:sp>
@@ -2227,7 +2652,7 @@
             <a:spLocks noGrp="1"/>
           </p:cNvSpPr>
           <p:nvPr>
-            <p:ph type="sldNum" sz="quarter" idx="12"/>
+            <p:ph type="sldNum" idx="12"/>
           </p:nvPr>
         </p:nvSpPr>
         <p:spPr/>
@@ -2236,19 +2661,13 @@
           <a:lstStyle/>
           <a:p>
             <a:fld id="{87FE6054-7650-435E-A483-FED81FA94D0F}" type="slidenum">
-              <a:rPr kumimoji="1" lang="ja-JP" altLang="en-US" smtClean="0"/>
               <a:t>‹#›</a:t>
             </a:fld>
-            <a:endParaRPr kumimoji="1" lang="ja-JP" altLang="en-US"/>
+            <a:endParaRPr/>
           </a:p>
         </p:txBody>
       </p:sp>
     </p:spTree>
-    <p:extLst>
-      <p:ext uri="{BB962C8B-B14F-4D97-AF65-F5344CB8AC3E}">
-        <p14:creationId xmlns:p14="http://schemas.microsoft.com/office/powerpoint/2010/main" val="588625517"/>
-      </p:ext>
-    </p:extLst>
   </p:cSld>
   <p:clrMapOvr>
     <a:masterClrMapping/>
@@ -2286,7 +2705,7 @@
             <a:spLocks noGrp="1"/>
           </p:cNvSpPr>
           <p:nvPr>
-            <p:ph type="dt" sz="half" idx="10"/>
+            <p:ph type="dt" idx="10"/>
           </p:nvPr>
         </p:nvSpPr>
         <p:spPr/>
@@ -2295,10 +2714,9 @@
           <a:lstStyle/>
           <a:p>
             <a:fld id="{3758AE5C-1802-44DF-8FF7-B9F28567BF0D}" type="datetimeFigureOut">
-              <a:rPr kumimoji="1" lang="ja-JP" altLang="en-US" smtClean="0"/>
-              <a:t>2026/7/18</a:t>
+              <a:t>2026/8/5</a:t>
             </a:fld>
-            <a:endParaRPr kumimoji="1" lang="ja-JP" altLang="en-US"/>
+            <a:endParaRPr/>
           </a:p>
         </p:txBody>
       </p:sp>
@@ -2315,7 +2733,7 @@
             <a:spLocks noGrp="1"/>
           </p:cNvSpPr>
           <p:nvPr>
-            <p:ph type="ftr" sz="quarter" idx="11"/>
+            <p:ph type="ftr" idx="11"/>
           </p:nvPr>
         </p:nvSpPr>
         <p:spPr/>
@@ -2323,7 +2741,7 @@
           <a:bodyPr/>
           <a:lstStyle/>
           <a:p>
-            <a:endParaRPr kumimoji="1" lang="ja-JP" altLang="en-US"/>
+            <a:endParaRPr/>
           </a:p>
         </p:txBody>
       </p:sp>
@@ -2340,7 +2758,7 @@
             <a:spLocks noGrp="1"/>
           </p:cNvSpPr>
           <p:nvPr>
-            <p:ph type="sldNum" sz="quarter" idx="12"/>
+            <p:ph type="sldNum" idx="12"/>
           </p:nvPr>
         </p:nvSpPr>
         <p:spPr/>
@@ -2349,19 +2767,13 @@
           <a:lstStyle/>
           <a:p>
             <a:fld id="{87FE6054-7650-435E-A483-FED81FA94D0F}" type="slidenum">
-              <a:rPr kumimoji="1" lang="ja-JP" altLang="en-US" smtClean="0"/>
               <a:t>‹#›</a:t>
             </a:fld>
-            <a:endParaRPr kumimoji="1" lang="ja-JP" altLang="en-US"/>
+            <a:endParaRPr/>
           </a:p>
         </p:txBody>
       </p:sp>
     </p:spTree>
-    <p:extLst>
-      <p:ext uri="{BB962C8B-B14F-4D97-AF65-F5344CB8AC3E}">
-        <p14:creationId xmlns:p14="http://schemas.microsoft.com/office/powerpoint/2010/main" val="496471293"/>
-      </p:ext>
-    </p:extLst>
   </p:cSld>
   <p:clrMapOvr>
     <a:masterClrMapping/>
@@ -2412,12 +2824,12 @@
           <a:bodyPr anchor="b"/>
           <a:lstStyle>
             <a:lvl1pPr>
+              <a:buNone/>
               <a:defRPr sz="3200"/>
             </a:lvl1pPr>
           </a:lstStyle>
           <a:p>
             <a:r>
-              <a:rPr kumimoji="1" lang="ja-JP" altLang="en-US"/>
               <a:t>マスター タイトルの書式設定</a:t>
             </a:r>
           </a:p>
@@ -2449,98 +2861,80 @@
           <a:bodyPr/>
           <a:lstStyle>
             <a:lvl1pPr>
+              <a:buNone/>
               <a:defRPr sz="3200"/>
             </a:lvl1pPr>
             <a:lvl2pPr>
+              <a:buNone/>
               <a:defRPr sz="2800"/>
             </a:lvl2pPr>
             <a:lvl3pPr>
+              <a:buNone/>
               <a:defRPr sz="2400"/>
             </a:lvl3pPr>
             <a:lvl4pPr>
+              <a:buNone/>
               <a:defRPr sz="2000"/>
             </a:lvl4pPr>
             <a:lvl5pPr>
+              <a:buNone/>
               <a:defRPr sz="2000"/>
             </a:lvl5pPr>
             <a:lvl6pPr>
+              <a:buNone/>
               <a:defRPr sz="2000"/>
             </a:lvl6pPr>
             <a:lvl7pPr>
+              <a:buNone/>
               <a:defRPr sz="2000"/>
             </a:lvl7pPr>
             <a:lvl8pPr>
+              <a:buNone/>
               <a:defRPr sz="2000"/>
             </a:lvl8pPr>
             <a:lvl9pPr>
+              <a:buNone/>
               <a:defRPr sz="2000"/>
             </a:lvl9pPr>
           </a:lstStyle>
           <a:p>
-            <a:pPr lvl="0"/>
-            <a:r>
-              <a:rPr kumimoji="1" lang="ja-JP" altLang="en-US"/>
+            <a:pPr lvl="0">
+              <a:buNone/>
+            </a:pPr>
+            <a:r>
               <a:t>マスター テキストの書式設定</a:t>
             </a:r>
           </a:p>
           <a:p>
-            <a:pPr lvl="1"/>
-            <a:r>
-              <a:rPr kumimoji="1" lang="ja-JP" altLang="en-US"/>
-              <a:t>第 </a:t>
-            </a:r>
-            <a:r>
-              <a:rPr kumimoji="1" lang="en-US" altLang="ja-JP"/>
-              <a:t>2 </a:t>
-            </a:r>
-            <a:r>
-              <a:rPr kumimoji="1" lang="ja-JP" altLang="en-US"/>
-              <a:t>レベル</a:t>
-            </a:r>
-          </a:p>
-          <a:p>
-            <a:pPr lvl="2"/>
-            <a:r>
-              <a:rPr kumimoji="1" lang="ja-JP" altLang="en-US"/>
-              <a:t>第 </a:t>
-            </a:r>
-            <a:r>
-              <a:rPr kumimoji="1" lang="en-US" altLang="ja-JP"/>
-              <a:t>3 </a:t>
-            </a:r>
-            <a:r>
-              <a:rPr kumimoji="1" lang="ja-JP" altLang="en-US"/>
-              <a:t>レベル</a:t>
-            </a:r>
-          </a:p>
-          <a:p>
-            <a:pPr lvl="3"/>
-            <a:r>
-              <a:rPr kumimoji="1" lang="ja-JP" altLang="en-US"/>
-              <a:t>第 </a:t>
-            </a:r>
-            <a:r>
-              <a:rPr kumimoji="1" lang="en-US" altLang="ja-JP"/>
-              <a:t>4 </a:t>
-            </a:r>
-            <a:r>
-              <a:rPr kumimoji="1" lang="ja-JP" altLang="en-US"/>
-              <a:t>レベル</a:t>
-            </a:r>
-          </a:p>
-          <a:p>
-            <a:pPr lvl="4"/>
-            <a:r>
-              <a:rPr kumimoji="1" lang="ja-JP" altLang="en-US"/>
-              <a:t>第 </a:t>
-            </a:r>
-            <a:r>
-              <a:rPr kumimoji="1" lang="en-US" altLang="ja-JP"/>
-              <a:t>5 </a:t>
-            </a:r>
-            <a:r>
-              <a:rPr kumimoji="1" lang="ja-JP" altLang="en-US"/>
-              <a:t>レベル</a:t>
+            <a:pPr lvl="1">
+              <a:buNone/>
+            </a:pPr>
+            <a:r>
+              <a:t>第 2 レベル</a:t>
+            </a:r>
+          </a:p>
+          <a:p>
+            <a:pPr lvl="2">
+              <a:buNone/>
+            </a:pPr>
+            <a:r>
+              <a:t>第 3 レベル</a:t>
+            </a:r>
+          </a:p>
+          <a:p>
+            <a:pPr lvl="3">
+              <a:buNone/>
+            </a:pPr>
+            <a:r>
+              <a:t>第 4 レベル</a:t>
+            </a:r>
+          </a:p>
+          <a:p>
+            <a:pPr lvl="4">
+              <a:buNone/>
+            </a:pPr>
+            <a:r>
+              <a:t>第 5 レベル</a:t>
             </a:r>
           </a:p>
         </p:txBody>
@@ -2558,7 +2952,7 @@
             <a:spLocks noGrp="1"/>
           </p:cNvSpPr>
           <p:nvPr>
-            <p:ph type="body" sz="half" idx="2"/>
+            <p:ph type="body" idx="2"/>
           </p:nvPr>
         </p:nvSpPr>
         <p:spPr>
@@ -2608,9 +3002,10 @@
             </a:lvl9pPr>
           </a:lstStyle>
           <a:p>
-            <a:pPr lvl="0"/>
-            <a:r>
-              <a:rPr kumimoji="1" lang="ja-JP" altLang="en-US"/>
+            <a:pPr lvl="0">
+              <a:buNone/>
+            </a:pPr>
+            <a:r>
               <a:t>マスター テキストの書式設定</a:t>
             </a:r>
           </a:p>
@@ -2629,7 +3024,7 @@
             <a:spLocks noGrp="1"/>
           </p:cNvSpPr>
           <p:nvPr>
-            <p:ph type="dt" sz="half" idx="10"/>
+            <p:ph type="dt" idx="10"/>
           </p:nvPr>
         </p:nvSpPr>
         <p:spPr/>
@@ -2638,10 +3033,9 @@
           <a:lstStyle/>
           <a:p>
             <a:fld id="{3758AE5C-1802-44DF-8FF7-B9F28567BF0D}" type="datetimeFigureOut">
-              <a:rPr kumimoji="1" lang="ja-JP" altLang="en-US" smtClean="0"/>
-              <a:t>2026/7/18</a:t>
+              <a:t>2026/8/5</a:t>
             </a:fld>
-            <a:endParaRPr kumimoji="1" lang="ja-JP" altLang="en-US"/>
+            <a:endParaRPr/>
           </a:p>
         </p:txBody>
       </p:sp>
@@ -2658,7 +3052,7 @@
             <a:spLocks noGrp="1"/>
           </p:cNvSpPr>
           <p:nvPr>
-            <p:ph type="ftr" sz="quarter" idx="11"/>
+            <p:ph type="ftr" idx="11"/>
           </p:nvPr>
         </p:nvSpPr>
         <p:spPr/>
@@ -2666,7 +3060,7 @@
           <a:bodyPr/>
           <a:lstStyle/>
           <a:p>
-            <a:endParaRPr kumimoji="1" lang="ja-JP" altLang="en-US"/>
+            <a:endParaRPr/>
           </a:p>
         </p:txBody>
       </p:sp>
@@ -2683,7 +3077,7 @@
             <a:spLocks noGrp="1"/>
           </p:cNvSpPr>
           <p:nvPr>
-            <p:ph type="sldNum" sz="quarter" idx="12"/>
+            <p:ph type="sldNum" idx="12"/>
           </p:nvPr>
         </p:nvSpPr>
         <p:spPr/>
@@ -2692,19 +3086,13 @@
           <a:lstStyle/>
           <a:p>
             <a:fld id="{87FE6054-7650-435E-A483-FED81FA94D0F}" type="slidenum">
-              <a:rPr kumimoji="1" lang="ja-JP" altLang="en-US" smtClean="0"/>
               <a:t>‹#›</a:t>
             </a:fld>
-            <a:endParaRPr kumimoji="1" lang="ja-JP" altLang="en-US"/>
+            <a:endParaRPr/>
           </a:p>
         </p:txBody>
       </p:sp>
     </p:spTree>
-    <p:extLst>
-      <p:ext uri="{BB962C8B-B14F-4D97-AF65-F5344CB8AC3E}">
-        <p14:creationId xmlns:p14="http://schemas.microsoft.com/office/powerpoint/2010/main" val="3961900616"/>
-      </p:ext>
-    </p:extLst>
   </p:cSld>
   <p:clrMapOvr>
     <a:masterClrMapping/>
@@ -2755,12 +3143,12 @@
           <a:bodyPr anchor="b"/>
           <a:lstStyle>
             <a:lvl1pPr>
+              <a:buNone/>
               <a:defRPr sz="3200"/>
             </a:lvl1pPr>
           </a:lstStyle>
           <a:p>
             <a:r>
-              <a:rPr kumimoji="1" lang="ja-JP" altLang="en-US"/>
               <a:t>マスター タイトルの書式設定</a:t>
             </a:r>
           </a:p>
@@ -2829,7 +3217,7 @@
             </a:lvl9pPr>
           </a:lstStyle>
           <a:p>
-            <a:endParaRPr kumimoji="1" lang="ja-JP" altLang="en-US"/>
+            <a:endParaRPr/>
           </a:p>
         </p:txBody>
       </p:sp>
@@ -2846,7 +3234,7 @@
             <a:spLocks noGrp="1"/>
           </p:cNvSpPr>
           <p:nvPr>
-            <p:ph type="body" sz="half" idx="2"/>
+            <p:ph type="body" idx="2"/>
           </p:nvPr>
         </p:nvSpPr>
         <p:spPr>
@@ -2896,9 +3284,10 @@
             </a:lvl9pPr>
           </a:lstStyle>
           <a:p>
-            <a:pPr lvl="0"/>
-            <a:r>
-              <a:rPr kumimoji="1" lang="ja-JP" altLang="en-US"/>
+            <a:pPr lvl="0">
+              <a:buNone/>
+            </a:pPr>
+            <a:r>
               <a:t>マスター テキストの書式設定</a:t>
             </a:r>
           </a:p>
@@ -2917,7 +3306,7 @@
             <a:spLocks noGrp="1"/>
           </p:cNvSpPr>
           <p:nvPr>
-            <p:ph type="dt" sz="half" idx="10"/>
+            <p:ph type="dt" idx="10"/>
           </p:nvPr>
         </p:nvSpPr>
         <p:spPr/>
@@ -2926,10 +3315,9 @@
           <a:lstStyle/>
           <a:p>
             <a:fld id="{3758AE5C-1802-44DF-8FF7-B9F28567BF0D}" type="datetimeFigureOut">
-              <a:rPr kumimoji="1" lang="ja-JP" altLang="en-US" smtClean="0"/>
-              <a:t>2026/7/18</a:t>
+              <a:t>2026/8/5</a:t>
             </a:fld>
-            <a:endParaRPr kumimoji="1" lang="ja-JP" altLang="en-US"/>
+            <a:endParaRPr/>
           </a:p>
         </p:txBody>
       </p:sp>
@@ -2946,7 +3334,7 @@
             <a:spLocks noGrp="1"/>
           </p:cNvSpPr>
           <p:nvPr>
-            <p:ph type="ftr" sz="quarter" idx="11"/>
+            <p:ph type="ftr" idx="11"/>
           </p:nvPr>
         </p:nvSpPr>
         <p:spPr/>
@@ -2954,7 +3342,7 @@
           <a:bodyPr/>
           <a:lstStyle/>
           <a:p>
-            <a:endParaRPr kumimoji="1" lang="ja-JP" altLang="en-US"/>
+            <a:endParaRPr/>
           </a:p>
         </p:txBody>
       </p:sp>
@@ -2971,7 +3359,7 @@
             <a:spLocks noGrp="1"/>
           </p:cNvSpPr>
           <p:nvPr>
-            <p:ph type="sldNum" sz="quarter" idx="12"/>
+            <p:ph type="sldNum" idx="12"/>
           </p:nvPr>
         </p:nvSpPr>
         <p:spPr/>
@@ -2980,19 +3368,13 @@
           <a:lstStyle/>
           <a:p>
             <a:fld id="{87FE6054-7650-435E-A483-FED81FA94D0F}" type="slidenum">
-              <a:rPr kumimoji="1" lang="ja-JP" altLang="en-US" smtClean="0"/>
               <a:t>‹#›</a:t>
             </a:fld>
-            <a:endParaRPr kumimoji="1" lang="ja-JP" altLang="en-US"/>
+            <a:endParaRPr/>
           </a:p>
         </p:txBody>
       </p:sp>
     </p:spTree>
-    <p:extLst>
-      <p:ext uri="{BB962C8B-B14F-4D97-AF65-F5344CB8AC3E}">
-        <p14:creationId xmlns:p14="http://schemas.microsoft.com/office/powerpoint/2010/main" val="2972926342"/>
-      </p:ext>
-    </p:extLst>
   </p:cSld>
   <p:clrMapOvr>
     <a:masterClrMapping/>
@@ -3048,13 +3430,12 @@
           </a:prstGeom>
         </p:spPr>
         <p:txBody>
-          <a:bodyPr vert="horz" lIns="91440" tIns="45720" rIns="91440" bIns="45720" rtlCol="0" anchor="ctr">
+          <a:bodyPr vert="horz" lIns="91440" tIns="45720" rIns="91440" bIns="45720" anchor="ctr">
             <a:normAutofit/>
           </a:bodyPr>
           <a:lstStyle/>
           <a:p>
             <a:r>
-              <a:rPr kumimoji="1" lang="ja-JP" altLang="en-US"/>
               <a:t>マスター タイトルの書式設定</a:t>
             </a:r>
           </a:p>
@@ -3086,75 +3467,48 @@
           </a:prstGeom>
         </p:spPr>
         <p:txBody>
-          <a:bodyPr vert="horz" lIns="91440" tIns="45720" rIns="91440" bIns="45720" rtlCol="0">
+          <a:bodyPr vert="horz" lIns="91440" tIns="45720" rIns="91440" bIns="45720">
             <a:normAutofit/>
           </a:bodyPr>
           <a:lstStyle/>
           <a:p>
-            <a:pPr lvl="0"/>
-            <a:r>
-              <a:rPr kumimoji="1" lang="ja-JP" altLang="en-US"/>
+            <a:pPr lvl="0">
+              <a:buNone/>
+            </a:pPr>
+            <a:r>
               <a:t>マスター テキストの書式設定</a:t>
             </a:r>
           </a:p>
           <a:p>
-            <a:pPr lvl="1"/>
-            <a:r>
-              <a:rPr kumimoji="1" lang="ja-JP" altLang="en-US"/>
-              <a:t>第 </a:t>
-            </a:r>
-            <a:r>
-              <a:rPr kumimoji="1" lang="en-US" altLang="ja-JP"/>
-              <a:t>2 </a:t>
-            </a:r>
-            <a:r>
-              <a:rPr kumimoji="1" lang="ja-JP" altLang="en-US"/>
-              <a:t>レベル</a:t>
-            </a:r>
-          </a:p>
-          <a:p>
-            <a:pPr lvl="2"/>
-            <a:r>
-              <a:rPr kumimoji="1" lang="ja-JP" altLang="en-US"/>
-              <a:t>第 </a:t>
-            </a:r>
-            <a:r>
-              <a:rPr kumimoji="1" lang="en-US" altLang="ja-JP"/>
-              <a:t>3 </a:t>
-            </a:r>
-            <a:r>
-              <a:rPr kumimoji="1" lang="ja-JP" altLang="en-US"/>
-              <a:t>レベル</a:t>
-            </a:r>
-          </a:p>
-          <a:p>
-            <a:pPr lvl="3"/>
-            <a:r>
-              <a:rPr kumimoji="1" lang="ja-JP" altLang="en-US"/>
-              <a:t>第 </a:t>
-            </a:r>
-            <a:r>
-              <a:rPr kumimoji="1" lang="en-US" altLang="ja-JP"/>
-              <a:t>4 </a:t>
-            </a:r>
-            <a:r>
-              <a:rPr kumimoji="1" lang="ja-JP" altLang="en-US"/>
-              <a:t>レベル</a:t>
-            </a:r>
-          </a:p>
-          <a:p>
-            <a:pPr lvl="4"/>
-            <a:r>
-              <a:rPr kumimoji="1" lang="ja-JP" altLang="en-US"/>
-              <a:t>第 </a:t>
-            </a:r>
-            <a:r>
-              <a:rPr kumimoji="1" lang="en-US" altLang="ja-JP"/>
-              <a:t>5 </a:t>
-            </a:r>
-            <a:r>
-              <a:rPr kumimoji="1" lang="ja-JP" altLang="en-US"/>
-              <a:t>レベル</a:t>
+            <a:pPr lvl="1">
+              <a:buNone/>
+            </a:pPr>
+            <a:r>
+              <a:t>第 2 レベル</a:t>
+            </a:r>
+          </a:p>
+          <a:p>
+            <a:pPr lvl="2">
+              <a:buNone/>
+            </a:pPr>
+            <a:r>
+              <a:t>第 3 レベル</a:t>
+            </a:r>
+          </a:p>
+          <a:p>
+            <a:pPr lvl="3">
+              <a:buNone/>
+            </a:pPr>
+            <a:r>
+              <a:t>第 4 レベル</a:t>
+            </a:r>
+          </a:p>
+          <a:p>
+            <a:pPr lvl="4">
+              <a:buNone/>
+            </a:pPr>
+            <a:r>
+              <a:t>第 5 レベル</a:t>
             </a:r>
           </a:p>
         </p:txBody>
@@ -3172,7 +3526,7 @@
             <a:spLocks noGrp="1"/>
           </p:cNvSpPr>
           <p:nvPr>
-            <p:ph type="dt" sz="half" idx="2"/>
+            <p:ph type="dt" idx="2"/>
           </p:nvPr>
         </p:nvSpPr>
         <p:spPr>
@@ -3185,9 +3539,10 @@
           </a:prstGeom>
         </p:spPr>
         <p:txBody>
-          <a:bodyPr vert="horz" lIns="91440" tIns="45720" rIns="91440" bIns="45720" rtlCol="0" anchor="ctr"/>
+          <a:bodyPr vert="horz" lIns="91440" tIns="45720" rIns="91440" bIns="45720" anchor="ctr"/>
           <a:lstStyle>
             <a:lvl1pPr algn="l">
+              <a:buNone/>
               <a:defRPr sz="1200">
                 <a:solidFill>
                   <a:schemeClr val="tx1">
@@ -3199,10 +3554,9 @@
           </a:lstStyle>
           <a:p>
             <a:fld id="{3758AE5C-1802-44DF-8FF7-B9F28567BF0D}" type="datetimeFigureOut">
-              <a:rPr kumimoji="1" lang="ja-JP" altLang="en-US" smtClean="0"/>
-              <a:t>2026/7/18</a:t>
+              <a:t>2026/8/5</a:t>
             </a:fld>
-            <a:endParaRPr kumimoji="1" lang="ja-JP" altLang="en-US"/>
+            <a:endParaRPr/>
           </a:p>
         </p:txBody>
       </p:sp>
@@ -3219,7 +3573,7 @@
             <a:spLocks noGrp="1"/>
           </p:cNvSpPr>
           <p:nvPr>
-            <p:ph type="ftr" sz="quarter" idx="3"/>
+            <p:ph type="ftr" idx="3"/>
           </p:nvPr>
         </p:nvSpPr>
         <p:spPr>
@@ -3232,9 +3586,10 @@
           </a:prstGeom>
         </p:spPr>
         <p:txBody>
-          <a:bodyPr vert="horz" lIns="91440" tIns="45720" rIns="91440" bIns="45720" rtlCol="0" anchor="ctr"/>
+          <a:bodyPr vert="horz" lIns="91440" tIns="45720" rIns="91440" bIns="45720" anchor="ctr"/>
           <a:lstStyle>
             <a:lvl1pPr algn="ctr">
+              <a:buNone/>
               <a:defRPr sz="1200">
                 <a:solidFill>
                   <a:schemeClr val="tx1">
@@ -3245,7 +3600,7 @@
             </a:lvl1pPr>
           </a:lstStyle>
           <a:p>
-            <a:endParaRPr kumimoji="1" lang="ja-JP" altLang="en-US"/>
+            <a:endParaRPr/>
           </a:p>
         </p:txBody>
       </p:sp>
@@ -3262,7 +3617,7 @@
             <a:spLocks noGrp="1"/>
           </p:cNvSpPr>
           <p:nvPr>
-            <p:ph type="sldNum" sz="quarter" idx="4"/>
+            <p:ph type="sldNum" idx="4"/>
           </p:nvPr>
         </p:nvSpPr>
         <p:spPr>
@@ -3275,9 +3630,10 @@
           </a:prstGeom>
         </p:spPr>
         <p:txBody>
-          <a:bodyPr vert="horz" lIns="91440" tIns="45720" rIns="91440" bIns="45720" rtlCol="0" anchor="ctr"/>
+          <a:bodyPr vert="horz" lIns="91440" tIns="45720" rIns="91440" bIns="45720" anchor="ctr"/>
           <a:lstStyle>
             <a:lvl1pPr algn="r">
+              <a:buNone/>
               <a:defRPr sz="1200">
                 <a:solidFill>
                   <a:schemeClr val="tx1">
@@ -3289,19 +3645,13 @@
           </a:lstStyle>
           <a:p>
             <a:fld id="{87FE6054-7650-435E-A483-FED81FA94D0F}" type="slidenum">
-              <a:rPr kumimoji="1" lang="ja-JP" altLang="en-US" smtClean="0"/>
               <a:t>‹#›</a:t>
             </a:fld>
-            <a:endParaRPr kumimoji="1" lang="ja-JP" altLang="en-US"/>
+            <a:endParaRPr/>
           </a:p>
         </p:txBody>
       </p:sp>
     </p:spTree>
-    <p:extLst>
-      <p:ext uri="{BB962C8B-B14F-4D97-AF65-F5344CB8AC3E}">
-        <p14:creationId xmlns:p14="http://schemas.microsoft.com/office/powerpoint/2010/main" val="226541572"/>
-      </p:ext>
-    </p:extLst>
   </p:cSld>
   <p:clrMap bg1="lt1" tx1="dk1" bg2="lt2" tx2="dk2" accent1="accent1" accent2="accent2" accent3="accent3" accent4="accent4" accent5="accent5" accent6="accent6" hlink="hlink" folHlink="folHlink"/>
   <p:sldLayoutIdLst>
@@ -3319,7 +3669,7 @@
   </p:sldLayoutIdLst>
   <p:txStyles>
     <p:titleStyle>
-      <a:lvl1pPr algn="l" defTabSz="914400" rtl="0" eaLnBrk="1" latinLnBrk="0" hangingPunct="1">
+      <a:lvl1pPr algn="l" defTabSz="914400">
         <a:lnSpc>
           <a:spcPct val="90000"/>
         </a:lnSpc>
@@ -3327,272 +3677,278 @@
           <a:spcPct val="0"/>
         </a:spcBef>
         <a:buNone/>
-        <a:defRPr kumimoji="1" sz="4400" kern="1200">
+        <a:defRPr sz="4400" kern="1200">
           <a:solidFill>
             <a:schemeClr val="tx1"/>
           </a:solidFill>
           <a:latin typeface="+mj-lt"/>
-          <a:ea typeface="+mj-ea"/>
-          <a:cs typeface="+mj-cs"/>
+          <a:ea typeface="+mj-lt"/>
+          <a:cs typeface="+mj-lt"/>
         </a:defRPr>
       </a:lvl1pPr>
     </p:titleStyle>
     <p:bodyStyle>
-      <a:lvl1pPr marL="228600" indent="-228600" algn="l" defTabSz="914400" rtl="0" eaLnBrk="1" latinLnBrk="0" hangingPunct="1">
+      <a:lvl1pPr marL="228600" indent="-228600" algn="l" defTabSz="914400">
         <a:lnSpc>
           <a:spcPct val="90000"/>
         </a:lnSpc>
         <a:spcBef>
           <a:spcPts val="1000"/>
         </a:spcBef>
-        <a:buFont typeface="Arial" panose="020B0604020202020204" pitchFamily="34" charset="0"/>
+        <a:buFont typeface="Arial"/>
         <a:buChar char="•"/>
-        <a:defRPr kumimoji="1" sz="2800" kern="1200">
+        <a:defRPr sz="2800" kern="1200">
           <a:solidFill>
             <a:schemeClr val="tx1"/>
           </a:solidFill>
           <a:latin typeface="+mn-lt"/>
-          <a:ea typeface="+mn-ea"/>
-          <a:cs typeface="+mn-cs"/>
+          <a:ea typeface="+mn-lt"/>
+          <a:cs typeface="+mn-lt"/>
         </a:defRPr>
       </a:lvl1pPr>
-      <a:lvl2pPr marL="685800" indent="-228600" algn="l" defTabSz="914400" rtl="0" eaLnBrk="1" latinLnBrk="0" hangingPunct="1">
+      <a:lvl2pPr marL="685800" indent="-228600" algn="l" defTabSz="914400">
         <a:lnSpc>
           <a:spcPct val="90000"/>
         </a:lnSpc>
         <a:spcBef>
           <a:spcPts val="500"/>
         </a:spcBef>
-        <a:buFont typeface="Arial" panose="020B0604020202020204" pitchFamily="34" charset="0"/>
+        <a:buFont typeface="Arial"/>
         <a:buChar char="•"/>
-        <a:defRPr kumimoji="1" sz="2400" kern="1200">
+        <a:defRPr sz="2400" kern="1200">
           <a:solidFill>
             <a:schemeClr val="tx1"/>
           </a:solidFill>
           <a:latin typeface="+mn-lt"/>
-          <a:ea typeface="+mn-ea"/>
-          <a:cs typeface="+mn-cs"/>
+          <a:ea typeface="+mn-lt"/>
+          <a:cs typeface="+mn-lt"/>
         </a:defRPr>
       </a:lvl2pPr>
-      <a:lvl3pPr marL="1143000" indent="-228600" algn="l" defTabSz="914400" rtl="0" eaLnBrk="1" latinLnBrk="0" hangingPunct="1">
+      <a:lvl3pPr marL="1143000" indent="-228600" algn="l" defTabSz="914400">
         <a:lnSpc>
           <a:spcPct val="90000"/>
         </a:lnSpc>
         <a:spcBef>
           <a:spcPts val="500"/>
         </a:spcBef>
-        <a:buFont typeface="Arial" panose="020B0604020202020204" pitchFamily="34" charset="0"/>
+        <a:buFont typeface="Arial"/>
         <a:buChar char="•"/>
-        <a:defRPr kumimoji="1" sz="2000" kern="1200">
+        <a:defRPr sz="2000" kern="1200">
           <a:solidFill>
             <a:schemeClr val="tx1"/>
           </a:solidFill>
           <a:latin typeface="+mn-lt"/>
-          <a:ea typeface="+mn-ea"/>
-          <a:cs typeface="+mn-cs"/>
+          <a:ea typeface="+mn-lt"/>
+          <a:cs typeface="+mn-lt"/>
         </a:defRPr>
       </a:lvl3pPr>
-      <a:lvl4pPr marL="1600200" indent="-228600" algn="l" defTabSz="914400" rtl="0" eaLnBrk="1" latinLnBrk="0" hangingPunct="1">
+      <a:lvl4pPr marL="1600200" indent="-228600" algn="l" defTabSz="914400">
         <a:lnSpc>
           <a:spcPct val="90000"/>
         </a:lnSpc>
         <a:spcBef>
           <a:spcPts val="500"/>
         </a:spcBef>
-        <a:buFont typeface="Arial" panose="020B0604020202020204" pitchFamily="34" charset="0"/>
+        <a:buFont typeface="Arial"/>
         <a:buChar char="•"/>
-        <a:defRPr kumimoji="1" sz="1800" kern="1200">
+        <a:defRPr sz="1800" kern="1200">
           <a:solidFill>
             <a:schemeClr val="tx1"/>
           </a:solidFill>
           <a:latin typeface="+mn-lt"/>
-          <a:ea typeface="+mn-ea"/>
-          <a:cs typeface="+mn-cs"/>
+          <a:ea typeface="+mn-lt"/>
+          <a:cs typeface="+mn-lt"/>
         </a:defRPr>
       </a:lvl4pPr>
-      <a:lvl5pPr marL="2057400" indent="-228600" algn="l" defTabSz="914400" rtl="0" eaLnBrk="1" latinLnBrk="0" hangingPunct="1">
+      <a:lvl5pPr marL="2057400" indent="-228600" algn="l" defTabSz="914400">
         <a:lnSpc>
           <a:spcPct val="90000"/>
         </a:lnSpc>
         <a:spcBef>
           <a:spcPts val="500"/>
         </a:spcBef>
-        <a:buFont typeface="Arial" panose="020B0604020202020204" pitchFamily="34" charset="0"/>
+        <a:buFont typeface="Arial"/>
         <a:buChar char="•"/>
-        <a:defRPr kumimoji="1" sz="1800" kern="1200">
+        <a:defRPr sz="1800" kern="1200">
           <a:solidFill>
             <a:schemeClr val="tx1"/>
           </a:solidFill>
           <a:latin typeface="+mn-lt"/>
-          <a:ea typeface="+mn-ea"/>
-          <a:cs typeface="+mn-cs"/>
+          <a:ea typeface="+mn-lt"/>
+          <a:cs typeface="+mn-lt"/>
         </a:defRPr>
       </a:lvl5pPr>
-      <a:lvl6pPr marL="2514600" indent="-228600" algn="l" defTabSz="914400" rtl="0" eaLnBrk="1" latinLnBrk="0" hangingPunct="1">
+      <a:lvl6pPr marL="2514600" indent="-228600" algn="l" defTabSz="914400">
         <a:lnSpc>
           <a:spcPct val="90000"/>
         </a:lnSpc>
         <a:spcBef>
           <a:spcPts val="500"/>
         </a:spcBef>
-        <a:buFont typeface="Arial" panose="020B0604020202020204" pitchFamily="34" charset="0"/>
+        <a:buFont typeface="Arial"/>
         <a:buChar char="•"/>
-        <a:defRPr kumimoji="1" sz="1800" kern="1200">
+        <a:defRPr sz="1800" kern="1200">
           <a:solidFill>
             <a:schemeClr val="tx1"/>
           </a:solidFill>
           <a:latin typeface="+mn-lt"/>
-          <a:ea typeface="+mn-ea"/>
-          <a:cs typeface="+mn-cs"/>
+          <a:ea typeface="+mn-lt"/>
+          <a:cs typeface="+mn-lt"/>
         </a:defRPr>
       </a:lvl6pPr>
-      <a:lvl7pPr marL="2971800" indent="-228600" algn="l" defTabSz="914400" rtl="0" eaLnBrk="1" latinLnBrk="0" hangingPunct="1">
+      <a:lvl7pPr marL="2971800" indent="-228600" algn="l" defTabSz="914400">
         <a:lnSpc>
           <a:spcPct val="90000"/>
         </a:lnSpc>
         <a:spcBef>
           <a:spcPts val="500"/>
         </a:spcBef>
-        <a:buFont typeface="Arial" panose="020B0604020202020204" pitchFamily="34" charset="0"/>
+        <a:buFont typeface="Arial"/>
         <a:buChar char="•"/>
-        <a:defRPr kumimoji="1" sz="1800" kern="1200">
+        <a:defRPr sz="1800" kern="1200">
           <a:solidFill>
             <a:schemeClr val="tx1"/>
           </a:solidFill>
           <a:latin typeface="+mn-lt"/>
-          <a:ea typeface="+mn-ea"/>
-          <a:cs typeface="+mn-cs"/>
+          <a:ea typeface="+mn-lt"/>
+          <a:cs typeface="+mn-lt"/>
         </a:defRPr>
       </a:lvl7pPr>
-      <a:lvl8pPr marL="3429000" indent="-228600" algn="l" defTabSz="914400" rtl="0" eaLnBrk="1" latinLnBrk="0" hangingPunct="1">
+      <a:lvl8pPr marL="3429000" indent="-228600" algn="l" defTabSz="914400">
         <a:lnSpc>
           <a:spcPct val="90000"/>
         </a:lnSpc>
         <a:spcBef>
           <a:spcPts val="500"/>
         </a:spcBef>
-        <a:buFont typeface="Arial" panose="020B0604020202020204" pitchFamily="34" charset="0"/>
+        <a:buFont typeface="Arial"/>
         <a:buChar char="•"/>
-        <a:defRPr kumimoji="1" sz="1800" kern="1200">
+        <a:defRPr sz="1800" kern="1200">
           <a:solidFill>
             <a:schemeClr val="tx1"/>
           </a:solidFill>
           <a:latin typeface="+mn-lt"/>
-          <a:ea typeface="+mn-ea"/>
-          <a:cs typeface="+mn-cs"/>
+          <a:ea typeface="+mn-lt"/>
+          <a:cs typeface="+mn-lt"/>
         </a:defRPr>
       </a:lvl8pPr>
-      <a:lvl9pPr marL="3886200" indent="-228600" algn="l" defTabSz="914400" rtl="0" eaLnBrk="1" latinLnBrk="0" hangingPunct="1">
+      <a:lvl9pPr marL="3886200" indent="-228600" algn="l" defTabSz="914400">
         <a:lnSpc>
           <a:spcPct val="90000"/>
         </a:lnSpc>
         <a:spcBef>
           <a:spcPts val="500"/>
         </a:spcBef>
-        <a:buFont typeface="Arial" panose="020B0604020202020204" pitchFamily="34" charset="0"/>
+        <a:buFont typeface="Arial"/>
         <a:buChar char="•"/>
-        <a:defRPr kumimoji="1" sz="1800" kern="1200">
+        <a:defRPr sz="1800" kern="1200">
           <a:solidFill>
             <a:schemeClr val="tx1"/>
           </a:solidFill>
           <a:latin typeface="+mn-lt"/>
-          <a:ea typeface="+mn-ea"/>
-          <a:cs typeface="+mn-cs"/>
+          <a:ea typeface="+mn-lt"/>
+          <a:cs typeface="+mn-lt"/>
         </a:defRPr>
       </a:lvl9pPr>
     </p:bodyStyle>
     <p:otherStyle>
-      <a:defPPr>
-        <a:defRPr lang="ja-JP"/>
-      </a:defPPr>
-      <a:lvl1pPr marL="0" algn="l" defTabSz="914400" rtl="0" eaLnBrk="1" latinLnBrk="0" hangingPunct="1">
-        <a:defRPr kumimoji="1" sz="1800" kern="1200">
+      <a:lvl1pPr marL="0" algn="l" defTabSz="914400">
+        <a:buNone/>
+        <a:defRPr sz="1800" kern="1200">
           <a:solidFill>
             <a:schemeClr val="tx1"/>
           </a:solidFill>
           <a:latin typeface="+mn-lt"/>
-          <a:ea typeface="+mn-ea"/>
-          <a:cs typeface="+mn-cs"/>
+          <a:ea typeface="+mn-lt"/>
+          <a:cs typeface="+mn-lt"/>
         </a:defRPr>
       </a:lvl1pPr>
-      <a:lvl2pPr marL="457200" algn="l" defTabSz="914400" rtl="0" eaLnBrk="1" latinLnBrk="0" hangingPunct="1">
-        <a:defRPr kumimoji="1" sz="1800" kern="1200">
+      <a:lvl2pPr marL="457200" algn="l" defTabSz="914400">
+        <a:buNone/>
+        <a:defRPr sz="1800" kern="1200">
           <a:solidFill>
             <a:schemeClr val="tx1"/>
           </a:solidFill>
           <a:latin typeface="+mn-lt"/>
-          <a:ea typeface="+mn-ea"/>
-          <a:cs typeface="+mn-cs"/>
+          <a:ea typeface="+mn-lt"/>
+          <a:cs typeface="+mn-lt"/>
         </a:defRPr>
       </a:lvl2pPr>
-      <a:lvl3pPr marL="914400" algn="l" defTabSz="914400" rtl="0" eaLnBrk="1" latinLnBrk="0" hangingPunct="1">
-        <a:defRPr kumimoji="1" sz="1800" kern="1200">
+      <a:lvl3pPr marL="914400" algn="l" defTabSz="914400">
+        <a:buNone/>
+        <a:defRPr sz="1800" kern="1200">
           <a:solidFill>
             <a:schemeClr val="tx1"/>
           </a:solidFill>
           <a:latin typeface="+mn-lt"/>
-          <a:ea typeface="+mn-ea"/>
-          <a:cs typeface="+mn-cs"/>
+          <a:ea typeface="+mn-lt"/>
+          <a:cs typeface="+mn-lt"/>
         </a:defRPr>
       </a:lvl3pPr>
-      <a:lvl4pPr marL="1371600" algn="l" defTabSz="914400" rtl="0" eaLnBrk="1" latinLnBrk="0" hangingPunct="1">
-        <a:defRPr kumimoji="1" sz="1800" kern="1200">
+      <a:lvl4pPr marL="1371600" algn="l" defTabSz="914400">
+        <a:buNone/>
+        <a:defRPr sz="1800" kern="1200">
           <a:solidFill>
             <a:schemeClr val="tx1"/>
           </a:solidFill>
           <a:latin typeface="+mn-lt"/>
-          <a:ea typeface="+mn-ea"/>
-          <a:cs typeface="+mn-cs"/>
+          <a:ea typeface="+mn-lt"/>
+          <a:cs typeface="+mn-lt"/>
         </a:defRPr>
       </a:lvl4pPr>
-      <a:lvl5pPr marL="1828800" algn="l" defTabSz="914400" rtl="0" eaLnBrk="1" latinLnBrk="0" hangingPunct="1">
-        <a:defRPr kumimoji="1" sz="1800" kern="1200">
+      <a:lvl5pPr marL="1828800" algn="l" defTabSz="914400">
+        <a:buNone/>
+        <a:defRPr sz="1800" kern="1200">
           <a:solidFill>
             <a:schemeClr val="tx1"/>
           </a:solidFill>
           <a:latin typeface="+mn-lt"/>
-          <a:ea typeface="+mn-ea"/>
-          <a:cs typeface="+mn-cs"/>
+          <a:ea typeface="+mn-lt"/>
+          <a:cs typeface="+mn-lt"/>
         </a:defRPr>
       </a:lvl5pPr>
-      <a:lvl6pPr marL="2286000" algn="l" defTabSz="914400" rtl="0" eaLnBrk="1" latinLnBrk="0" hangingPunct="1">
-        <a:defRPr kumimoji="1" sz="1800" kern="1200">
+      <a:lvl6pPr marL="2286000" algn="l" defTabSz="914400">
+        <a:buNone/>
+        <a:defRPr sz="1800" kern="1200">
           <a:solidFill>
             <a:schemeClr val="tx1"/>
           </a:solidFill>
           <a:latin typeface="+mn-lt"/>
-          <a:ea typeface="+mn-ea"/>
-          <a:cs typeface="+mn-cs"/>
+          <a:ea typeface="+mn-lt"/>
+          <a:cs typeface="+mn-lt"/>
         </a:defRPr>
       </a:lvl6pPr>
-      <a:lvl7pPr marL="2743200" algn="l" defTabSz="914400" rtl="0" eaLnBrk="1" latinLnBrk="0" hangingPunct="1">
-        <a:defRPr kumimoji="1" sz="1800" kern="1200">
+      <a:lvl7pPr marL="2743200" algn="l" defTabSz="914400">
+        <a:buNone/>
+        <a:defRPr sz="1800" kern="1200">
           <a:solidFill>
             <a:schemeClr val="tx1"/>
           </a:solidFill>
           <a:latin typeface="+mn-lt"/>
-          <a:ea typeface="+mn-ea"/>
-          <a:cs typeface="+mn-cs"/>
+          <a:ea typeface="+mn-lt"/>
+          <a:cs typeface="+mn-lt"/>
         </a:defRPr>
       </a:lvl7pPr>
-      <a:lvl8pPr marL="3200400" algn="l" defTabSz="914400" rtl="0" eaLnBrk="1" latinLnBrk="0" hangingPunct="1">
-        <a:defRPr kumimoji="1" sz="1800" kern="1200">
+      <a:lvl8pPr marL="3200400" algn="l" defTabSz="914400">
+        <a:buNone/>
+        <a:defRPr sz="1800" kern="1200">
           <a:solidFill>
             <a:schemeClr val="tx1"/>
           </a:solidFill>
           <a:latin typeface="+mn-lt"/>
-          <a:ea typeface="+mn-ea"/>
-          <a:cs typeface="+mn-cs"/>
+          <a:ea typeface="+mn-lt"/>
+          <a:cs typeface="+mn-lt"/>
         </a:defRPr>
       </a:lvl8pPr>
-      <a:lvl9pPr marL="3657600" algn="l" defTabSz="914400" rtl="0" eaLnBrk="1" latinLnBrk="0" hangingPunct="1">
-        <a:defRPr kumimoji="1" sz="1800" kern="1200">
+      <a:lvl9pPr marL="3657600" algn="l" defTabSz="914400">
+        <a:buNone/>
+        <a:defRPr sz="1800" kern="1200">
           <a:solidFill>
             <a:schemeClr val="tx1"/>
           </a:solidFill>
           <a:latin typeface="+mn-lt"/>
-          <a:ea typeface="+mn-ea"/>
-          <a:cs typeface="+mn-cs"/>
+          <a:ea typeface="+mn-lt"/>
+          <a:cs typeface="+mn-lt"/>
         </a:defRPr>
       </a:lvl9pPr>
     </p:otherStyle>
@@ -3619,24 +3975,16 @@
       </p:grpSpPr>
       <p:pic>
         <p:nvPicPr>
-          <p:cNvPr id="7" name="図 6" descr="The image displays a video editing software interface, featuring a selection of video segments with various durations, confidence levels, and transcripts, arranged in a timeline for audio editing and transcription.&#10;&#10;AI 生成コンテンツは誤りを含む可能性があります。">
-            <a:extLst>
-              <a:ext uri="{FF2B5EF4-FFF2-40B4-BE49-F238E27FC236}">
-                <a16:creationId xmlns:a16="http://schemas.microsoft.com/office/drawing/2014/main" id="{0E82FA78-672D-603C-DE43-A23E6799F617}"/>
-              </a:ext>
-            </a:extLst>
-          </p:cNvPr>
+          <p:cNvPr id="17" name="図 16"/>
           <p:cNvPicPr>
             <a:picLocks noChangeAspect="1"/>
           </p:cNvPicPr>
           <p:nvPr/>
         </p:nvPicPr>
         <p:blipFill>
-          <a:blip r:embed="rId2"/>
+          <a:blip r:embed="rId3"/>
           <a:srcRect b="5278"/>
-          <a:stretch>
-            <a:fillRect/>
-          </a:stretch>
+          <a:stretch/>
         </p:blipFill>
         <p:spPr>
           <a:xfrm>
@@ -3657,7 +4005,9 @@
               </a:ext>
             </a:extLst>
           </p:cNvPr>
-          <p:cNvSpPr/>
+          <p:cNvSpPr>
+            <a:spLocks noGrp="1"/>
+          </p:cNvSpPr>
           <p:nvPr/>
         </p:nvSpPr>
         <p:spPr>
@@ -3697,15 +4047,15 @@
           </a:fontRef>
         </p:style>
         <p:txBody>
-          <a:bodyPr rtlCol="0" anchor="ctr"/>
-          <a:lstStyle/>
-          <a:p>
-            <a:pPr algn="ctr"/>
-            <a:r>
-              <a:rPr kumimoji="1" lang="en-US" altLang="ja-JP" dirty="0"/>
-              <a:t>1. Select “Load” to load movie</a:t>
-            </a:r>
-            <a:endParaRPr kumimoji="1" lang="ja-JP" altLang="en-US" dirty="0"/>
+          <a:bodyPr anchor="ctr"/>
+          <a:lstStyle/>
+          <a:p>
+            <a:pPr algn="ctr">
+              <a:buNone/>
+            </a:pPr>
+            <a:r>
+              <a:t>1. 読み込む / Load</a:t>
+            </a:r>
           </a:p>
         </p:txBody>
       </p:sp>
@@ -3718,7 +4068,9 @@
               </a:ext>
             </a:extLst>
           </p:cNvPr>
-          <p:cNvSpPr/>
+          <p:cNvSpPr>
+            <a:spLocks noGrp="1"/>
+          </p:cNvSpPr>
           <p:nvPr/>
         </p:nvSpPr>
         <p:spPr>
@@ -3758,15 +4110,15 @@
           </a:fontRef>
         </p:style>
         <p:txBody>
-          <a:bodyPr rtlCol="0" anchor="ctr"/>
-          <a:lstStyle/>
-          <a:p>
-            <a:pPr algn="ctr"/>
-            <a:r>
-              <a:rPr kumimoji="1" lang="en-US" altLang="ja-JP" dirty="0"/>
-              <a:t>3. Select “Analysis”</a:t>
-            </a:r>
-            <a:endParaRPr kumimoji="1" lang="ja-JP" altLang="en-US" dirty="0"/>
+          <a:bodyPr anchor="ctr"/>
+          <a:lstStyle/>
+          <a:p>
+            <a:pPr algn="ctr">
+              <a:buNone/>
+            </a:pPr>
+            <a:r>
+              <a:t>3. 解析 / Analyze</a:t>
+            </a:r>
           </a:p>
         </p:txBody>
       </p:sp>
@@ -3779,7 +4131,9 @@
               </a:ext>
             </a:extLst>
           </p:cNvPr>
-          <p:cNvSpPr/>
+          <p:cNvSpPr>
+            <a:spLocks noGrp="1"/>
+          </p:cNvSpPr>
           <p:nvPr/>
         </p:nvSpPr>
         <p:spPr>
@@ -3817,19 +4171,15 @@
           </a:fontRef>
         </p:style>
         <p:txBody>
-          <a:bodyPr rtlCol="0" anchor="ctr"/>
-          <a:lstStyle/>
-          <a:p>
-            <a:pPr algn="ctr"/>
-            <a:r>
-              <a:rPr kumimoji="1" lang="en-US" altLang="ja-JP" dirty="0"/>
-              <a:t>2. </a:t>
-            </a:r>
-            <a:r>
-              <a:rPr lang="en-US" altLang="ja-JP" dirty="0"/>
-              <a:t>Paste TS Comment if you have</a:t>
-            </a:r>
-            <a:endParaRPr kumimoji="1" lang="ja-JP" altLang="en-US" dirty="0"/>
+          <a:bodyPr anchor="ctr"/>
+          <a:lstStyle/>
+          <a:p>
+            <a:pPr algn="ctr">
+              <a:buNone/>
+            </a:pPr>
+            <a:r>
+              <a:t>2. ガイドを貼る / Paste guide</a:t>
+            </a:r>
           </a:p>
         </p:txBody>
       </p:sp>
@@ -3865,24 +4215,16 @@
       </p:grpSpPr>
       <p:pic>
         <p:nvPicPr>
-          <p:cNvPr id="3" name="図 2" descr="The image displays a video editing software interface, featuring a selection of video segments with various durations, confidence levels, and transcripts, arranged in a timeline for audio editing and transcription.&#10;&#10;AI 生成コンテンツは誤りを含む可能性があります。">
-            <a:extLst>
-              <a:ext uri="{FF2B5EF4-FFF2-40B4-BE49-F238E27FC236}">
-                <a16:creationId xmlns:a16="http://schemas.microsoft.com/office/drawing/2014/main" id="{E6FD022F-A741-7B68-B280-9CD0B8BC4B82}"/>
-              </a:ext>
-            </a:extLst>
-          </p:cNvPr>
+          <p:cNvPr id="19" name="図 18"/>
           <p:cNvPicPr>
             <a:picLocks noChangeAspect="1"/>
           </p:cNvPicPr>
           <p:nvPr/>
         </p:nvPicPr>
         <p:blipFill>
-          <a:blip r:embed="rId2"/>
+          <a:blip r:embed="rId3"/>
           <a:srcRect b="5278"/>
-          <a:stretch>
-            <a:fillRect/>
-          </a:stretch>
+          <a:stretch/>
         </p:blipFill>
         <p:spPr>
           <a:xfrm>
@@ -3903,7 +4245,9 @@
               </a:ext>
             </a:extLst>
           </p:cNvPr>
-          <p:cNvSpPr/>
+          <p:cNvSpPr>
+            <a:spLocks noGrp="1"/>
+          </p:cNvSpPr>
           <p:nvPr/>
         </p:nvSpPr>
         <p:spPr>
@@ -3943,19 +4287,15 @@
           </a:fontRef>
         </p:style>
         <p:txBody>
-          <a:bodyPr rtlCol="0" anchor="ctr"/>
-          <a:lstStyle/>
-          <a:p>
-            <a:pPr algn="ctr"/>
-            <a:r>
-              <a:rPr kumimoji="1" lang="en-US" altLang="ja-JP" dirty="0"/>
-              <a:t>1. Select </a:t>
-            </a:r>
-            <a:r>
-              <a:rPr lang="en-US" altLang="ja-JP" dirty="0"/>
-              <a:t>segment to edit</a:t>
-            </a:r>
-            <a:endParaRPr kumimoji="1" lang="ja-JP" altLang="en-US" dirty="0"/>
+          <a:bodyPr anchor="ctr"/>
+          <a:lstStyle/>
+          <a:p>
+            <a:pPr algn="ctr">
+              <a:buNone/>
+            </a:pPr>
+            <a:r>
+              <a:t>1. セグメントを選択 / Select</a:t>
+            </a:r>
           </a:p>
         </p:txBody>
       </p:sp>
@@ -3968,7 +4308,9 @@
               </a:ext>
             </a:extLst>
           </p:cNvPr>
-          <p:cNvSpPr/>
+          <p:cNvSpPr>
+            <a:spLocks noGrp="1"/>
+          </p:cNvSpPr>
           <p:nvPr/>
         </p:nvSpPr>
         <p:spPr>
@@ -4008,15 +4350,15 @@
           </a:fontRef>
         </p:style>
         <p:txBody>
-          <a:bodyPr rtlCol="0" anchor="ctr"/>
-          <a:lstStyle/>
-          <a:p>
-            <a:pPr algn="ctr"/>
-            <a:r>
-              <a:rPr kumimoji="1" lang="en-US" altLang="ja-JP" dirty="0"/>
-              <a:t>2. Edit title by click</a:t>
-            </a:r>
-            <a:endParaRPr kumimoji="1" lang="ja-JP" altLang="en-US" dirty="0"/>
+          <a:bodyPr anchor="ctr"/>
+          <a:lstStyle/>
+          <a:p>
+            <a:pPr algn="ctr">
+              <a:buNone/>
+            </a:pPr>
+            <a:r>
+              <a:t>2. タイトル編集 / Edit title</a:t>
+            </a:r>
           </a:p>
         </p:txBody>
       </p:sp>
@@ -4029,7 +4371,9 @@
               </a:ext>
             </a:extLst>
           </p:cNvPr>
-          <p:cNvSpPr/>
+          <p:cNvSpPr>
+            <a:spLocks noGrp="1"/>
+          </p:cNvSpPr>
           <p:nvPr/>
         </p:nvSpPr>
         <p:spPr>
@@ -4069,19 +4413,15 @@
           </a:fontRef>
         </p:style>
         <p:txBody>
-          <a:bodyPr rtlCol="0" anchor="ctr"/>
-          <a:lstStyle/>
-          <a:p>
-            <a:pPr algn="ctr"/>
-            <a:r>
-              <a:rPr kumimoji="1" lang="en-US" altLang="ja-JP" dirty="0"/>
-              <a:t>3. </a:t>
-            </a:r>
-            <a:r>
-              <a:rPr lang="en-US" altLang="ja-JP" dirty="0"/>
-              <a:t>Edit start-end position of segment by mouse drag</a:t>
-            </a:r>
-            <a:endParaRPr kumimoji="1" lang="ja-JP" altLang="en-US" dirty="0"/>
+          <a:bodyPr anchor="ctr"/>
+          <a:lstStyle/>
+          <a:p>
+            <a:pPr algn="ctr">
+              <a:buNone/>
+            </a:pPr>
+            <a:r>
+              <a:t>3. 境界をドラッグ / Drag boundary</a:t>
+            </a:r>
           </a:p>
         </p:txBody>
       </p:sp>
@@ -4094,7 +4434,9 @@
               </a:ext>
             </a:extLst>
           </p:cNvPr>
-          <p:cNvSpPr/>
+          <p:cNvSpPr>
+            <a:spLocks noGrp="1"/>
+          </p:cNvSpPr>
           <p:nvPr/>
         </p:nvSpPr>
         <p:spPr>
@@ -4134,19 +4476,15 @@
           </a:fontRef>
         </p:style>
         <p:txBody>
-          <a:bodyPr rtlCol="0" anchor="ctr"/>
-          <a:lstStyle/>
-          <a:p>
-            <a:pPr algn="ctr"/>
-            <a:r>
-              <a:rPr kumimoji="1" lang="en-US" altLang="ja-JP" dirty="0"/>
-              <a:t>4. </a:t>
-            </a:r>
-            <a:r>
-              <a:rPr lang="ja-JP" altLang="ja-JP" dirty="0"/>
-              <a:t>Select for export</a:t>
-            </a:r>
-            <a:endParaRPr kumimoji="1" lang="ja-JP" altLang="en-US" dirty="0"/>
+          <a:bodyPr anchor="ctr"/>
+          <a:lstStyle/>
+          <a:p>
+            <a:pPr algn="ctr">
+              <a:buNone/>
+            </a:pPr>
+            <a:r>
+              <a:t>4. 書き出し対象 / Export</a:t>
+            </a:r>
           </a:p>
         </p:txBody>
       </p:sp>
@@ -4168,13 +4506,7 @@
   <p:cSld>
     <p:spTree>
       <p:nvGrpSpPr>
-        <p:cNvPr id="1" name="">
-          <a:extLst>
-            <a:ext uri="{FF2B5EF4-FFF2-40B4-BE49-F238E27FC236}">
-              <a16:creationId xmlns:a16="http://schemas.microsoft.com/office/drawing/2014/main" id="{3C2F0CBB-AED7-3781-D8F0-491F18E90D38}"/>
-            </a:ext>
-          </a:extLst>
-        </p:cNvPr>
+        <p:cNvPr id="1" name=""/>
         <p:cNvGrpSpPr/>
         <p:nvPr/>
       </p:nvGrpSpPr>
@@ -4188,29 +4520,21 @@
       </p:grpSpPr>
       <p:pic>
         <p:nvPicPr>
-          <p:cNvPr id="5" name="図 4" descr="The image displays a video editing software interface, featuring a selection of video segments with various durations, confidence levels, and transcripts, arranged in a timeline for audio editing and transcription.&#10;&#10;AI 生成コンテンツは誤りを含む可能性があります。">
-            <a:extLst>
-              <a:ext uri="{FF2B5EF4-FFF2-40B4-BE49-F238E27FC236}">
-                <a16:creationId xmlns:a16="http://schemas.microsoft.com/office/drawing/2014/main" id="{69D0A3C5-8561-305B-C87C-F8792D426A99}"/>
-              </a:ext>
-            </a:extLst>
-          </p:cNvPr>
+          <p:cNvPr id="17" name="図 16"/>
           <p:cNvPicPr>
             <a:picLocks noChangeAspect="1"/>
           </p:cNvPicPr>
           <p:nvPr/>
         </p:nvPicPr>
         <p:blipFill>
-          <a:blip r:embed="rId2"/>
+          <a:blip r:embed="rId3"/>
           <a:srcRect l="49476" b="43983"/>
-          <a:stretch>
-            <a:fillRect/>
-          </a:stretch>
+          <a:stretch/>
         </p:blipFill>
         <p:spPr>
           <a:xfrm>
             <a:off x="710143" y="0"/>
-            <a:ext cx="9883095" cy="6848452"/>
+            <a:ext cx="11158937" cy="6858000"/>
           </a:xfrm>
           <a:prstGeom prst="rect">
             <a:avLst/>
@@ -4226,20 +4550,22 @@
               </a:ext>
             </a:extLst>
           </p:cNvPr>
-          <p:cNvSpPr/>
+          <p:cNvSpPr>
+            <a:spLocks noGrp="1"/>
+          </p:cNvSpPr>
           <p:nvPr/>
         </p:nvSpPr>
         <p:spPr>
           <a:xfrm>
-            <a:off x="2656936" y="3243532"/>
+            <a:off x="1037686" y="3710257"/>
             <a:ext cx="2421146" cy="678612"/>
           </a:xfrm>
           <a:prstGeom prst="borderCallout1">
             <a:avLst>
               <a:gd name="adj1" fmla="val 114513"/>
               <a:gd name="adj2" fmla="val 82515"/>
-              <a:gd name="adj3" fmla="val 155720"/>
-              <a:gd name="adj4" fmla="val 99790"/>
+              <a:gd name="adj3" fmla="val 157124"/>
+              <a:gd name="adj4" fmla="val 78939"/>
             </a:avLst>
           </a:prstGeom>
           <a:solidFill>
@@ -4264,22 +4590,20 @@
           </a:fontRef>
         </p:style>
         <p:txBody>
-          <a:bodyPr rtlCol="0" anchor="ctr"/>
-          <a:lstStyle/>
-          <a:p>
-            <a:pPr algn="ctr"/>
-            <a:r>
-              <a:rPr kumimoji="1" lang="en-US" altLang="ja-JP" dirty="0"/>
-              <a:t>Segment boundary</a:t>
-            </a:r>
-            <a:br>
-              <a:rPr kumimoji="1" lang="en-US" altLang="ja-JP" dirty="0"/>
-            </a:br>
-            <a:r>
-              <a:rPr kumimoji="1" lang="en-US" altLang="ja-JP" dirty="0"/>
-              <a:t>preview tool</a:t>
-            </a:r>
-            <a:endParaRPr kumimoji="1" lang="ja-JP" altLang="en-US" dirty="0"/>
+          <a:bodyPr anchor="ctr"/>
+          <a:lstStyle/>
+          <a:p>
+            <a:pPr algn="ctr">
+              <a:buNone/>
+            </a:pPr>
+            <a:r>
+              <a:rPr dirty="0" err="1"/>
+              <a:t>境界を試聴</a:t>
+            </a:r>
+            <a:r>
+              <a:rPr dirty="0"/>
+              <a:t> / Preview</a:t>
+            </a:r>
           </a:p>
         </p:txBody>
       </p:sp>
@@ -4292,12 +4616,14 @@
               </a:ext>
             </a:extLst>
           </p:cNvPr>
-          <p:cNvSpPr/>
+          <p:cNvSpPr>
+            <a:spLocks noGrp="1"/>
+          </p:cNvSpPr>
           <p:nvPr/>
         </p:nvSpPr>
         <p:spPr>
           <a:xfrm>
-            <a:off x="5264695" y="3243532"/>
+            <a:off x="3786375" y="3710257"/>
             <a:ext cx="3039668" cy="678612"/>
           </a:xfrm>
           <a:prstGeom prst="borderCallout1">
@@ -4330,22 +4656,15 @@
           </a:fontRef>
         </p:style>
         <p:txBody>
-          <a:bodyPr rtlCol="0" anchor="ctr"/>
-          <a:lstStyle/>
-          <a:p>
-            <a:pPr algn="ctr"/>
-            <a:r>
-              <a:rPr lang="en-US" altLang="ja-JP" dirty="0"/>
-              <a:t>Segment boundary</a:t>
-            </a:r>
-            <a:br>
-              <a:rPr lang="en-US" altLang="ja-JP" dirty="0"/>
-            </a:br>
-            <a:r>
-              <a:rPr lang="en-US" altLang="ja-JP" dirty="0"/>
-              <a:t>micro adjustment tool</a:t>
-            </a:r>
-            <a:endParaRPr lang="ja-JP" altLang="en-US" dirty="0"/>
+          <a:bodyPr anchor="ctr"/>
+          <a:lstStyle/>
+          <a:p>
+            <a:pPr algn="ctr">
+              <a:buNone/>
+            </a:pPr>
+            <a:r>
+              <a:t>境界を微調整 / Nudge</a:t>
+            </a:r>
           </a:p>
         </p:txBody>
       </p:sp>
@@ -4358,12 +4677,14 @@
               </a:ext>
             </a:extLst>
           </p:cNvPr>
-          <p:cNvSpPr/>
+          <p:cNvSpPr>
+            <a:spLocks noGrp="1"/>
+          </p:cNvSpPr>
           <p:nvPr/>
         </p:nvSpPr>
         <p:spPr>
           <a:xfrm>
-            <a:off x="5877464" y="5094414"/>
+            <a:off x="5877464" y="5561139"/>
             <a:ext cx="2055964" cy="678612"/>
           </a:xfrm>
           <a:prstGeom prst="borderCallout1">
@@ -4396,15 +4717,15 @@
           </a:fontRef>
         </p:style>
         <p:txBody>
-          <a:bodyPr rtlCol="0" anchor="ctr"/>
-          <a:lstStyle/>
-          <a:p>
-            <a:pPr algn="ctr"/>
-            <a:r>
-              <a:rPr lang="en-US" altLang="ja-JP" dirty="0"/>
-              <a:t>Playback tool</a:t>
-            </a:r>
-            <a:endParaRPr lang="ja-JP" altLang="en-US" dirty="0"/>
+          <a:bodyPr anchor="ctr"/>
+          <a:lstStyle/>
+          <a:p>
+            <a:pPr algn="ctr">
+              <a:buNone/>
+            </a:pPr>
+            <a:r>
+              <a:t>再生 / Playback</a:t>
+            </a:r>
           </a:p>
         </p:txBody>
       </p:sp>
@@ -4417,12 +4738,14 @@
               </a:ext>
             </a:extLst>
           </p:cNvPr>
-          <p:cNvSpPr/>
+          <p:cNvSpPr>
+            <a:spLocks noGrp="1"/>
+          </p:cNvSpPr>
           <p:nvPr/>
         </p:nvSpPr>
         <p:spPr>
           <a:xfrm>
-            <a:off x="8235351" y="5094414"/>
+            <a:off x="9330726" y="5561139"/>
             <a:ext cx="2055964" cy="678612"/>
           </a:xfrm>
           <a:prstGeom prst="borderCallout1">
@@ -4455,22 +4778,20 @@
           </a:fontRef>
         </p:style>
         <p:txBody>
-          <a:bodyPr rtlCol="0" anchor="ctr"/>
-          <a:lstStyle/>
-          <a:p>
-            <a:pPr algn="ctr"/>
-            <a:r>
-              <a:rPr lang="en-US" altLang="ja-JP" dirty="0"/>
-              <a:t>Timeline zoom</a:t>
-            </a:r>
-            <a:br>
-              <a:rPr lang="en-US" altLang="ja-JP" dirty="0"/>
-            </a:br>
-            <a:r>
-              <a:rPr lang="en-US" altLang="ja-JP" dirty="0"/>
-              <a:t>tool</a:t>
-            </a:r>
-            <a:endParaRPr lang="ja-JP" altLang="en-US" dirty="0"/>
+          <a:bodyPr anchor="ctr"/>
+          <a:lstStyle/>
+          <a:p>
+            <a:pPr algn="ctr">
+              <a:buNone/>
+            </a:pPr>
+            <a:r>
+              <a:rPr dirty="0" err="1"/>
+              <a:t>拡大・縮小</a:t>
+            </a:r>
+            <a:r>
+              <a:rPr dirty="0"/>
+              <a:t> / Zoom</a:t>
+            </a:r>
           </a:p>
         </p:txBody>
       </p:sp>
@@ -4504,76 +4825,325 @@
           <a:chExt cx="0" cy="0"/>
         </a:xfrm>
       </p:grpSpPr>
-      <p:sp>
-        <p:nvSpPr>
-          <p:cNvPr id="2" name="タイトル 1">
-            <a:extLst>
-              <a:ext uri="{FF2B5EF4-FFF2-40B4-BE49-F238E27FC236}">
-                <a16:creationId xmlns:a16="http://schemas.microsoft.com/office/drawing/2014/main" id="{EAE23AAE-B7F8-B220-9437-2AEC289C8A53}"/>
-              </a:ext>
-            </a:extLst>
-          </p:cNvPr>
-          <p:cNvSpPr>
-            <a:spLocks noGrp="1"/>
-          </p:cNvSpPr>
-          <p:nvPr>
-            <p:ph type="title"/>
-          </p:nvPr>
-        </p:nvSpPr>
-        <p:spPr/>
-        <p:txBody>
-          <a:bodyPr/>
-          <a:lstStyle/>
-          <a:p>
-            <a:endParaRPr kumimoji="1" lang="ja-JP" altLang="en-US"/>
-          </a:p>
-        </p:txBody>
-      </p:sp>
-      <p:sp>
-        <p:nvSpPr>
-          <p:cNvPr id="3" name="コンテンツ プレースホルダー 2">
-            <a:extLst>
-              <a:ext uri="{FF2B5EF4-FFF2-40B4-BE49-F238E27FC236}">
-                <a16:creationId xmlns:a16="http://schemas.microsoft.com/office/drawing/2014/main" id="{EBA6ABFB-2BF9-CD4F-0EC5-343E1AF3E328}"/>
-              </a:ext>
-            </a:extLst>
-          </p:cNvPr>
-          <p:cNvSpPr>
-            <a:spLocks noGrp="1"/>
-          </p:cNvSpPr>
-          <p:nvPr>
-            <p:ph idx="1"/>
-          </p:nvPr>
-        </p:nvSpPr>
-        <p:spPr/>
-        <p:txBody>
-          <a:bodyPr/>
-          <a:lstStyle/>
-          <a:p>
-            <a:endParaRPr kumimoji="1" lang="ja-JP" altLang="en-US"/>
-          </a:p>
-        </p:txBody>
-      </p:sp>
       <p:pic>
         <p:nvPicPr>
-          <p:cNvPr id="7" name="図 6" descr="The image displays a video editing software interface, featuring a selection of video segments with various durations, confidence levels, and transcripts, arranged in a timeline for audio editing and transcription.&#10;&#10;AI 生成コンテンツは誤りを含む可能性があります。">
-            <a:extLst>
-              <a:ext uri="{FF2B5EF4-FFF2-40B4-BE49-F238E27FC236}">
-                <a16:creationId xmlns:a16="http://schemas.microsoft.com/office/drawing/2014/main" id="{1DE8941E-B84E-CB18-A675-F866F7804BEC}"/>
-              </a:ext>
-            </a:extLst>
-          </p:cNvPr>
+          <p:cNvPr id="2" name="図 1"/>
           <p:cNvPicPr>
             <a:picLocks noChangeAspect="1"/>
           </p:cNvPicPr>
           <p:nvPr/>
         </p:nvPicPr>
         <p:blipFill>
-          <a:blip r:embed="rId2"/>
+          <a:blip r:embed="rId3"/>
           <a:srcRect b="5278"/>
-          <a:stretch>
-            <a:fillRect/>
-          </a:stretch>
+          <a:stretch/>
+        </p:blipFill>
+        <p:spPr>
+          <a:xfrm>
+            <a:off x="303906" y="0"/>
+            <a:ext cx="11584188" cy="6858000"/>
+          </a:xfrm>
+          <a:prstGeom prst="rect">
+            <a:avLst/>
+          </a:prstGeom>
+        </p:spPr>
+      </p:pic>
+    </p:spTree>
+    <p:extLst>
+      <p:ext uri="{BB962C8B-B14F-4D97-AF65-F5344CB8AC3E}">
+        <p14:creationId xmlns:p14="http://schemas.microsoft.com/office/powerpoint/2010/main" val="2347541153"/>
+      </p:ext>
+    </p:extLst>
+  </p:cSld>
+  <p:clrMapOvr>
+    <a:masterClrMapping/>
+  </p:clrMapOvr>
+</p:sld>
+</file>
+
+<file path=ppt/slides/slide5.xml><?xml version="1.0" encoding="utf-8"?>
+<p:sld xmlns:a="http://schemas.openxmlformats.org/drawingml/2006/main" xmlns:r="http://schemas.openxmlformats.org/officeDocument/2006/relationships" xmlns:p="http://schemas.openxmlformats.org/presentationml/2006/main">
+  <p:cSld>
+    <p:spTree>
+      <p:nvGrpSpPr>
+        <p:cNvPr id="1" name=""/>
+        <p:cNvGrpSpPr/>
+        <p:nvPr/>
+      </p:nvGrpSpPr>
+      <p:grpSpPr>
+        <a:xfrm>
+          <a:off x="0" y="0"/>
+          <a:ext cx="0" cy="0"/>
+          <a:chOff x="0" y="0"/>
+          <a:chExt cx="0" cy="0"/>
+        </a:xfrm>
+      </p:grpSpPr>
+      <p:pic>
+        <p:nvPicPr>
+          <p:cNvPr id="17" name="図 16"/>
+          <p:cNvPicPr>
+            <a:picLocks noChangeAspect="1"/>
+          </p:cNvPicPr>
+          <p:nvPr/>
+        </p:nvPicPr>
+        <p:blipFill>
+          <a:blip r:embed="rId3"/>
+          <a:srcRect b="5278"/>
+          <a:stretch/>
+        </p:blipFill>
+        <p:spPr>
+          <a:xfrm>
+            <a:off x="303906" y="0"/>
+            <a:ext cx="11584188" cy="6858000"/>
+          </a:xfrm>
+          <a:prstGeom prst="rect">
+            <a:avLst/>
+          </a:prstGeom>
+        </p:spPr>
+      </p:pic>
+      <p:sp>
+        <p:nvSpPr>
+          <p:cNvPr id="8" name="吹き出し: 折線 7">
+            <a:extLst>
+              <a:ext uri="{FF2B5EF4-FFF2-40B4-BE49-F238E27FC236}">
+                <a16:creationId xmlns:a16="http://schemas.microsoft.com/office/drawing/2014/main" id="{5AE52448-7D4B-9208-1E52-037140F65472}"/>
+              </a:ext>
+            </a:extLst>
+          </p:cNvPr>
+          <p:cNvSpPr>
+            <a:spLocks noGrp="1"/>
+          </p:cNvSpPr>
+          <p:nvPr/>
+        </p:nvSpPr>
+        <p:spPr>
+          <a:xfrm>
+            <a:off x="2483038" y="994975"/>
+            <a:ext cx="3612962" cy="402026"/>
+          </a:xfrm>
+          <a:prstGeom prst="borderCallout2">
+            <a:avLst>
+              <a:gd name="adj1" fmla="val 18750"/>
+              <a:gd name="adj2" fmla="val -8333"/>
+              <a:gd name="adj3" fmla="val 18750"/>
+              <a:gd name="adj4" fmla="val -16667"/>
+              <a:gd name="adj5" fmla="val 440717"/>
+              <a:gd name="adj6" fmla="val -24609"/>
+            </a:avLst>
+          </a:prstGeom>
+          <a:solidFill>
+            <a:schemeClr val="tx2">
+              <a:lumMod val="25000"/>
+              <a:lumOff val="75000"/>
+            </a:schemeClr>
+          </a:solidFill>
+        </p:spPr>
+        <p:style>
+          <a:lnRef idx="2">
+            <a:schemeClr val="accent4"/>
+          </a:lnRef>
+          <a:fillRef idx="1">
+            <a:schemeClr val="lt1"/>
+          </a:fillRef>
+          <a:effectRef idx="0">
+            <a:schemeClr val="accent4"/>
+          </a:effectRef>
+          <a:fontRef idx="minor">
+            <a:schemeClr val="dk1"/>
+          </a:fontRef>
+        </p:style>
+        <p:txBody>
+          <a:bodyPr anchor="ctr"/>
+          <a:lstStyle/>
+          <a:p>
+            <a:pPr algn="ctr">
+              <a:buNone/>
+            </a:pPr>
+            <a:r>
+              <a:t>1. 解析 / Analyze lyrics</a:t>
+            </a:r>
+          </a:p>
+        </p:txBody>
+      </p:sp>
+      <p:sp>
+        <p:nvSpPr>
+          <p:cNvPr id="10" name="吹き出し: 折線 9">
+            <a:extLst>
+              <a:ext uri="{FF2B5EF4-FFF2-40B4-BE49-F238E27FC236}">
+                <a16:creationId xmlns:a16="http://schemas.microsoft.com/office/drawing/2014/main" id="{AB2A44AA-071F-91FB-4271-68F36D507063}"/>
+              </a:ext>
+            </a:extLst>
+          </p:cNvPr>
+          <p:cNvSpPr>
+            <a:spLocks noGrp="1"/>
+          </p:cNvSpPr>
+          <p:nvPr/>
+        </p:nvSpPr>
+        <p:spPr>
+          <a:xfrm>
+            <a:off x="6493709" y="4677976"/>
+            <a:ext cx="3221791" cy="402026"/>
+          </a:xfrm>
+          <a:prstGeom prst="borderCallout2">
+            <a:avLst>
+              <a:gd name="adj1" fmla="val 18750"/>
+              <a:gd name="adj2" fmla="val -8333"/>
+              <a:gd name="adj3" fmla="val 18750"/>
+              <a:gd name="adj4" fmla="val -16667"/>
+              <a:gd name="adj5" fmla="val 154194"/>
+              <a:gd name="adj6" fmla="val -27601"/>
+            </a:avLst>
+          </a:prstGeom>
+          <a:solidFill>
+            <a:schemeClr val="tx2">
+              <a:lumMod val="25000"/>
+              <a:lumOff val="75000"/>
+            </a:schemeClr>
+          </a:solidFill>
+        </p:spPr>
+        <p:style>
+          <a:lnRef idx="2">
+            <a:schemeClr val="accent4"/>
+          </a:lnRef>
+          <a:fillRef idx="1">
+            <a:schemeClr val="lt1"/>
+          </a:fillRef>
+          <a:effectRef idx="0">
+            <a:schemeClr val="accent4"/>
+          </a:effectRef>
+          <a:fontRef idx="minor">
+            <a:schemeClr val="dk1"/>
+          </a:fontRef>
+        </p:style>
+        <p:txBody>
+          <a:bodyPr anchor="ctr"/>
+          <a:lstStyle/>
+          <a:p>
+            <a:pPr algn="ctr">
+              <a:buNone/>
+            </a:pPr>
+            <a:r>
+              <a:rPr dirty="0"/>
+              <a:t>2. </a:t>
+            </a:r>
+            <a:r>
+              <a:rPr lang="ja-JP" altLang="en-US" dirty="0"/>
+              <a:t>タイムライン</a:t>
+            </a:r>
+            <a:r>
+              <a:rPr dirty="0"/>
+              <a:t> / </a:t>
+            </a:r>
+            <a:r>
+              <a:rPr lang="en-US" altLang="ja-JP" dirty="0"/>
+              <a:t>Timelines</a:t>
+            </a:r>
+            <a:endParaRPr dirty="0"/>
+          </a:p>
+        </p:txBody>
+      </p:sp>
+      <p:sp>
+        <p:nvSpPr>
+          <p:cNvPr id="12" name="吹き出し: 線 11">
+            <a:extLst>
+              <a:ext uri="{FF2B5EF4-FFF2-40B4-BE49-F238E27FC236}">
+                <a16:creationId xmlns:a16="http://schemas.microsoft.com/office/drawing/2014/main" id="{57104A7E-C31F-F25B-0F24-8406E3319190}"/>
+              </a:ext>
+            </a:extLst>
+          </p:cNvPr>
+          <p:cNvSpPr>
+            <a:spLocks noGrp="1"/>
+          </p:cNvSpPr>
+          <p:nvPr/>
+        </p:nvSpPr>
+        <p:spPr>
+          <a:xfrm>
+            <a:off x="2048201" y="3902100"/>
+            <a:ext cx="4110736" cy="450800"/>
+          </a:xfrm>
+          <a:prstGeom prst="borderCallout1">
+            <a:avLst>
+              <a:gd name="adj1" fmla="val 64530"/>
+              <a:gd name="adj2" fmla="val -1614"/>
+              <a:gd name="adj3" fmla="val 291393"/>
+              <a:gd name="adj4" fmla="val -16244"/>
+            </a:avLst>
+          </a:prstGeom>
+          <a:solidFill>
+            <a:schemeClr val="tx2">
+              <a:lumMod val="25000"/>
+              <a:lumOff val="75000"/>
+            </a:schemeClr>
+          </a:solidFill>
+        </p:spPr>
+        <p:style>
+          <a:lnRef idx="2">
+            <a:schemeClr val="accent4"/>
+          </a:lnRef>
+          <a:fillRef idx="1">
+            <a:schemeClr val="lt1"/>
+          </a:fillRef>
+          <a:effectRef idx="0">
+            <a:schemeClr val="accent4"/>
+          </a:effectRef>
+          <a:fontRef idx="minor">
+            <a:schemeClr val="dk1"/>
+          </a:fontRef>
+        </p:style>
+        <p:txBody>
+          <a:bodyPr anchor="ctr"/>
+          <a:lstStyle/>
+          <a:p>
+            <a:pPr algn="ctr">
+              <a:buNone/>
+            </a:pPr>
+            <a:r>
+              <a:t>3. スタイル / Style</a:t>
+            </a:r>
+          </a:p>
+        </p:txBody>
+      </p:sp>
+    </p:spTree>
+    <p:extLst>
+      <p:ext uri="{BB962C8B-B14F-4D97-AF65-F5344CB8AC3E}">
+        <p14:creationId xmlns:p14="http://schemas.microsoft.com/office/powerpoint/2010/main" val="2976815354"/>
+      </p:ext>
+    </p:extLst>
+  </p:cSld>
+  <p:clrMapOvr>
+    <a:masterClrMapping/>
+  </p:clrMapOvr>
+</p:sld>
+</file>
+
+<file path=ppt/slides/slide6.xml><?xml version="1.0" encoding="utf-8"?>
+<p:sld xmlns:a="http://schemas.openxmlformats.org/drawingml/2006/main" xmlns:r="http://schemas.openxmlformats.org/officeDocument/2006/relationships" xmlns:p="http://schemas.openxmlformats.org/presentationml/2006/main">
+  <p:cSld>
+    <p:spTree>
+      <p:nvGrpSpPr>
+        <p:cNvPr id="1" name=""/>
+        <p:cNvGrpSpPr/>
+        <p:nvPr/>
+      </p:nvGrpSpPr>
+      <p:grpSpPr>
+        <a:xfrm>
+          <a:off x="0" y="0"/>
+          <a:ext cx="0" cy="0"/>
+          <a:chOff x="0" y="0"/>
+          <a:chExt cx="0" cy="0"/>
+        </a:xfrm>
+      </p:grpSpPr>
+      <p:pic>
+        <p:nvPicPr>
+          <p:cNvPr id="2" name="図 1"/>
+          <p:cNvPicPr>
+            <a:picLocks noChangeAspect="1"/>
+          </p:cNvPicPr>
+          <p:nvPr/>
+        </p:nvPicPr>
+        <p:blipFill>
+          <a:blip r:embed="rId3"/>
+          <a:srcRect b="5278"/>
+          <a:stretch/>
         </p:blipFill>
         <p:spPr>
           <a:xfrm>
@@ -4641,7 +5211,7 @@
     </a:clrScheme>
     <a:fontScheme name="Office">
       <a:majorFont>
-        <a:latin typeface="游ゴシック Light" panose="02110004020202020204"/>
+        <a:latin typeface="游ゴシック Light"/>
         <a:ea typeface=""/>
         <a:cs typeface=""/>
         <a:font script="Jpan" typeface="游ゴシック Light"/>
@@ -4693,7 +5263,7 @@
         <a:font script="Tfng" typeface="Ebrima"/>
       </a:majorFont>
       <a:minorFont>
-        <a:latin typeface="游ゴシック" panose="02110004020202020204"/>
+        <a:latin typeface="游ゴシック"/>
         <a:ea typeface=""/>
         <a:cs typeface=""/>
         <a:font script="Jpan" typeface="游ゴシック"/>
@@ -4754,23 +5324,23 @@
           <a:gsLst>
             <a:gs pos="0">
               <a:schemeClr val="phClr">
+                <a:tint val="67000"/>
                 <a:lumMod val="110000"/>
                 <a:satMod val="105000"/>
-                <a:tint val="67000"/>
               </a:schemeClr>
             </a:gs>
             <a:gs pos="50000">
               <a:schemeClr val="phClr">
+                <a:tint val="73000"/>
                 <a:lumMod val="105000"/>
                 <a:satMod val="103000"/>
-                <a:tint val="73000"/>
               </a:schemeClr>
             </a:gs>
             <a:gs pos="100000">
               <a:schemeClr val="phClr">
+                <a:tint val="81000"/>
                 <a:lumMod val="105000"/>
                 <a:satMod val="109000"/>
-                <a:tint val="81000"/>
               </a:schemeClr>
             </a:gs>
           </a:gsLst>
@@ -4780,23 +5350,23 @@
           <a:gsLst>
             <a:gs pos="0">
               <a:schemeClr val="phClr">
+                <a:tint val="94000"/>
+                <a:lumMod val="102000"/>
                 <a:satMod val="103000"/>
-                <a:lumMod val="102000"/>
-                <a:tint val="94000"/>
               </a:schemeClr>
             </a:gs>
             <a:gs pos="50000">
               <a:schemeClr val="phClr">
+                <a:shade val="100000"/>
+                <a:lumMod val="100000"/>
                 <a:satMod val="110000"/>
-                <a:lumMod val="100000"/>
-                <a:shade val="100000"/>
               </a:schemeClr>
             </a:gs>
             <a:gs pos="100000">
               <a:schemeClr val="phClr">
+                <a:shade val="78000"/>
                 <a:lumMod val="99000"/>
                 <a:satMod val="120000"/>
-                <a:shade val="78000"/>
               </a:schemeClr>
             </a:gs>
           </a:gsLst>
@@ -4804,26 +5374,23 @@
         </a:gradFill>
       </a:fillStyleLst>
       <a:lnStyleLst>
-        <a:ln w="12700" cap="flat" cmpd="sng" algn="ctr">
+        <a:ln w="12700">
           <a:solidFill>
             <a:schemeClr val="phClr"/>
           </a:solidFill>
           <a:prstDash val="solid"/>
-          <a:miter lim="800000"/>
         </a:ln>
-        <a:ln w="19050" cap="flat" cmpd="sng" algn="ctr">
+        <a:ln w="19050">
           <a:solidFill>
             <a:schemeClr val="phClr"/>
           </a:solidFill>
           <a:prstDash val="solid"/>
-          <a:miter lim="800000"/>
         </a:ln>
-        <a:ln w="25400" cap="flat" cmpd="sng" algn="ctr">
+        <a:ln w="25400">
           <a:solidFill>
             <a:schemeClr val="phClr"/>
           </a:solidFill>
           <a:prstDash val="solid"/>
-          <a:miter lim="800000"/>
         </a:ln>
       </a:lnStyleLst>
       <a:effectStyleLst>
@@ -4858,17 +5425,17 @@
             <a:gs pos="0">
               <a:schemeClr val="phClr">
                 <a:tint val="93000"/>
-                <a:satMod val="150000"/>
                 <a:shade val="98000"/>
                 <a:lumMod val="102000"/>
+                <a:satMod val="150000"/>
               </a:schemeClr>
             </a:gs>
             <a:gs pos="50000">
               <a:schemeClr val="phClr">
                 <a:tint val="98000"/>
-                <a:satMod val="130000"/>
                 <a:shade val="90000"/>
                 <a:lumMod val="103000"/>
+                <a:satMod val="130000"/>
               </a:schemeClr>
             </a:gs>
             <a:gs pos="100000">
@@ -4883,32 +5450,294 @@
       </a:bgFillStyleLst>
     </a:fmtScheme>
   </a:themeElements>
-  <a:objectDefaults>
-    <a:lnDef>
-      <a:spPr/>
-      <a:bodyPr/>
-      <a:lstStyle/>
-      <a:style>
-        <a:lnRef idx="2">
-          <a:schemeClr val="accent1"/>
-        </a:lnRef>
-        <a:fillRef idx="0">
-          <a:schemeClr val="accent1"/>
-        </a:fillRef>
-        <a:effectRef idx="1">
-          <a:schemeClr val="accent1"/>
-        </a:effectRef>
-        <a:fontRef idx="minor">
-          <a:schemeClr val="tx1"/>
-        </a:fontRef>
-      </a:style>
-    </a:lnDef>
-  </a:objectDefaults>
+  <a:objectDefaults/>
   <a:extraClrSchemeLst/>
-  <a:extLst>
-    <a:ext uri="{05A4C25C-085E-4340-85A3-A5531E510DB2}">
-      <thm15:themeFamily xmlns:thm15="http://schemas.microsoft.com/office/thememl/2012/main" name="Office Theme" id="{2E142A2C-CD16-42D6-873A-C26D2A0506FA}" vid="{1BDDFF52-6CD6-40A5-AB3C-68EB2F1E4D0A}"/>
-    </a:ext>
-  </a:extLst>
+</a:theme>
+</file>
+
+<file path=ppt/theme/theme2.xml><?xml version="1.0" encoding="utf-8"?>
+<a:theme xmlns:a="http://schemas.openxmlformats.org/drawingml/2006/main" name="Office テーマ">
+  <a:themeElements>
+    <a:clrScheme name="Office">
+      <a:dk1>
+        <a:sysClr val="windowText" lastClr="000000"/>
+      </a:dk1>
+      <a:lt1>
+        <a:sysClr val="window" lastClr="FFFFFF"/>
+      </a:lt1>
+      <a:dk2>
+        <a:srgbClr val="0E2841"/>
+      </a:dk2>
+      <a:lt2>
+        <a:srgbClr val="E8E8E8"/>
+      </a:lt2>
+      <a:accent1>
+        <a:srgbClr val="156082"/>
+      </a:accent1>
+      <a:accent2>
+        <a:srgbClr val="E97132"/>
+      </a:accent2>
+      <a:accent3>
+        <a:srgbClr val="196B24"/>
+      </a:accent3>
+      <a:accent4>
+        <a:srgbClr val="0F9ED5"/>
+      </a:accent4>
+      <a:accent5>
+        <a:srgbClr val="A02B93"/>
+      </a:accent5>
+      <a:accent6>
+        <a:srgbClr val="4EA72E"/>
+      </a:accent6>
+      <a:hlink>
+        <a:srgbClr val="467886"/>
+      </a:hlink>
+      <a:folHlink>
+        <a:srgbClr val="96607D"/>
+      </a:folHlink>
+    </a:clrScheme>
+    <a:fontScheme name="Office">
+      <a:majorFont>
+        <a:latin typeface="游ゴシック Light"/>
+        <a:ea typeface=""/>
+        <a:cs typeface=""/>
+        <a:font script="Jpan" typeface="游ゴシック Light"/>
+        <a:font script="Hang" typeface="맑은 고딕"/>
+        <a:font script="Hans" typeface="等线 Light"/>
+        <a:font script="Hant" typeface="新細明體"/>
+        <a:font script="Arab" typeface="Times New Roman"/>
+        <a:font script="Hebr" typeface="Times New Roman"/>
+        <a:font script="Thai" typeface="Angsana New"/>
+        <a:font script="Ethi" typeface="Nyala"/>
+        <a:font script="Beng" typeface="Vrinda"/>
+        <a:font script="Gujr" typeface="Shruti"/>
+        <a:font script="Khmr" typeface="MoolBoran"/>
+        <a:font script="Knda" typeface="Tunga"/>
+        <a:font script="Guru" typeface="Raavi"/>
+        <a:font script="Cans" typeface="Euphemia"/>
+        <a:font script="Cher" typeface="Plantagenet Cherokee"/>
+        <a:font script="Yiii" typeface="Microsoft Yi Baiti"/>
+        <a:font script="Tibt" typeface="Microsoft Himalaya"/>
+        <a:font script="Thaa" typeface="MV Boli"/>
+        <a:font script="Deva" typeface="Mangal"/>
+        <a:font script="Telu" typeface="Gautami"/>
+        <a:font script="Taml" typeface="Latha"/>
+        <a:font script="Syrc" typeface="Estrangelo Edessa"/>
+        <a:font script="Orya" typeface="Kalinga"/>
+        <a:font script="Mlym" typeface="Kartika"/>
+        <a:font script="Laoo" typeface="DokChampa"/>
+        <a:font script="Sinh" typeface="Iskoola Pota"/>
+        <a:font script="Mong" typeface="Mongolian Baiti"/>
+        <a:font script="Viet" typeface="Times New Roman"/>
+        <a:font script="Uigh" typeface="Microsoft Uighur"/>
+        <a:font script="Geor" typeface="Sylfaen"/>
+        <a:font script="Armn" typeface="Arial"/>
+        <a:font script="Bugi" typeface="Leelawadee UI"/>
+        <a:font script="Bopo" typeface="Microsoft JhengHei"/>
+        <a:font script="Java" typeface="Javanese Text"/>
+        <a:font script="Lisu" typeface="Segoe UI"/>
+        <a:font script="Mymr" typeface="Myanmar Text"/>
+        <a:font script="Nkoo" typeface="Ebrima"/>
+        <a:font script="Olck" typeface="Nirmala UI"/>
+        <a:font script="Osma" typeface="Ebrima"/>
+        <a:font script="Phag" typeface="Phagspa"/>
+        <a:font script="Syrn" typeface="Estrangelo Edessa"/>
+        <a:font script="Syrj" typeface="Estrangelo Edessa"/>
+        <a:font script="Syre" typeface="Estrangelo Edessa"/>
+        <a:font script="Sora" typeface="Nirmala UI"/>
+        <a:font script="Tale" typeface="Microsoft Tai Le"/>
+        <a:font script="Talu" typeface="Microsoft New Tai Lue"/>
+        <a:font script="Tfng" typeface="Ebrima"/>
+      </a:majorFont>
+      <a:minorFont>
+        <a:latin typeface="游ゴシック"/>
+        <a:ea typeface=""/>
+        <a:cs typeface=""/>
+        <a:font script="Jpan" typeface="游ゴシック"/>
+        <a:font script="Hang" typeface="맑은 고딕"/>
+        <a:font script="Hans" typeface="等线"/>
+        <a:font script="Hant" typeface="新細明體"/>
+        <a:font script="Arab" typeface="Arial"/>
+        <a:font script="Hebr" typeface="Arial"/>
+        <a:font script="Thai" typeface="Cordia New"/>
+        <a:font script="Ethi" typeface="Nyala"/>
+        <a:font script="Beng" typeface="Vrinda"/>
+        <a:font script="Gujr" typeface="Shruti"/>
+        <a:font script="Khmr" typeface="DaunPenh"/>
+        <a:font script="Knda" typeface="Tunga"/>
+        <a:font script="Guru" typeface="Raavi"/>
+        <a:font script="Cans" typeface="Euphemia"/>
+        <a:font script="Cher" typeface="Plantagenet Cherokee"/>
+        <a:font script="Yiii" typeface="Microsoft Yi Baiti"/>
+        <a:font script="Tibt" typeface="Microsoft Himalaya"/>
+        <a:font script="Thaa" typeface="MV Boli"/>
+        <a:font script="Deva" typeface="Mangal"/>
+        <a:font script="Telu" typeface="Gautami"/>
+        <a:font script="Taml" typeface="Latha"/>
+        <a:font script="Syrc" typeface="Estrangelo Edessa"/>
+        <a:font script="Orya" typeface="Kalinga"/>
+        <a:font script="Mlym" typeface="Kartika"/>
+        <a:font script="Laoo" typeface="DokChampa"/>
+        <a:font script="Sinh" typeface="Iskoola Pota"/>
+        <a:font script="Mong" typeface="Mongolian Baiti"/>
+        <a:font script="Viet" typeface="Arial"/>
+        <a:font script="Uigh" typeface="Microsoft Uighur"/>
+        <a:font script="Geor" typeface="Sylfaen"/>
+        <a:font script="Armn" typeface="Arial"/>
+        <a:font script="Bugi" typeface="Leelawadee UI"/>
+        <a:font script="Bopo" typeface="Microsoft JhengHei"/>
+        <a:font script="Java" typeface="Javanese Text"/>
+        <a:font script="Lisu" typeface="Segoe UI"/>
+        <a:font script="Mymr" typeface="Myanmar Text"/>
+        <a:font script="Nkoo" typeface="Ebrima"/>
+        <a:font script="Olck" typeface="Nirmala UI"/>
+        <a:font script="Osma" typeface="Ebrima"/>
+        <a:font script="Phag" typeface="Phagspa"/>
+        <a:font script="Syrn" typeface="Estrangelo Edessa"/>
+        <a:font script="Syrj" typeface="Estrangelo Edessa"/>
+        <a:font script="Syre" typeface="Estrangelo Edessa"/>
+        <a:font script="Sora" typeface="Nirmala UI"/>
+        <a:font script="Tale" typeface="Microsoft Tai Le"/>
+        <a:font script="Talu" typeface="Microsoft New Tai Lue"/>
+        <a:font script="Tfng" typeface="Ebrima"/>
+      </a:minorFont>
+    </a:fontScheme>
+    <a:fmtScheme name="Office">
+      <a:fillStyleLst>
+        <a:solidFill>
+          <a:schemeClr val="phClr"/>
+        </a:solidFill>
+        <a:gradFill rotWithShape="1">
+          <a:gsLst>
+            <a:gs pos="0">
+              <a:schemeClr val="phClr">
+                <a:tint val="67000"/>
+                <a:lumMod val="110000"/>
+                <a:satMod val="105000"/>
+              </a:schemeClr>
+            </a:gs>
+            <a:gs pos="50000">
+              <a:schemeClr val="phClr">
+                <a:tint val="73000"/>
+                <a:lumMod val="105000"/>
+                <a:satMod val="103000"/>
+              </a:schemeClr>
+            </a:gs>
+            <a:gs pos="100000">
+              <a:schemeClr val="phClr">
+                <a:tint val="81000"/>
+                <a:lumMod val="105000"/>
+                <a:satMod val="109000"/>
+              </a:schemeClr>
+            </a:gs>
+          </a:gsLst>
+          <a:lin ang="5400000" scaled="0"/>
+        </a:gradFill>
+        <a:gradFill rotWithShape="1">
+          <a:gsLst>
+            <a:gs pos="0">
+              <a:schemeClr val="phClr">
+                <a:tint val="94000"/>
+                <a:lumMod val="102000"/>
+                <a:satMod val="103000"/>
+              </a:schemeClr>
+            </a:gs>
+            <a:gs pos="50000">
+              <a:schemeClr val="phClr">
+                <a:shade val="100000"/>
+                <a:lumMod val="100000"/>
+                <a:satMod val="110000"/>
+              </a:schemeClr>
+            </a:gs>
+            <a:gs pos="100000">
+              <a:schemeClr val="phClr">
+                <a:shade val="78000"/>
+                <a:lumMod val="99000"/>
+                <a:satMod val="120000"/>
+              </a:schemeClr>
+            </a:gs>
+          </a:gsLst>
+          <a:lin ang="5400000" scaled="0"/>
+        </a:gradFill>
+      </a:fillStyleLst>
+      <a:lnStyleLst>
+        <a:ln w="12700">
+          <a:solidFill>
+            <a:schemeClr val="phClr"/>
+          </a:solidFill>
+          <a:prstDash val="solid"/>
+        </a:ln>
+        <a:ln w="19050">
+          <a:solidFill>
+            <a:schemeClr val="phClr"/>
+          </a:solidFill>
+          <a:prstDash val="solid"/>
+        </a:ln>
+        <a:ln w="25400">
+          <a:solidFill>
+            <a:schemeClr val="phClr"/>
+          </a:solidFill>
+          <a:prstDash val="solid"/>
+        </a:ln>
+      </a:lnStyleLst>
+      <a:effectStyleLst>
+        <a:effectStyle>
+          <a:effectLst/>
+        </a:effectStyle>
+        <a:effectStyle>
+          <a:effectLst/>
+        </a:effectStyle>
+        <a:effectStyle>
+          <a:effectLst>
+            <a:outerShdw blurRad="57150" dist="19050" dir="5400000" algn="ctr" rotWithShape="0">
+              <a:srgbClr val="000000">
+                <a:alpha val="63000"/>
+              </a:srgbClr>
+            </a:outerShdw>
+          </a:effectLst>
+        </a:effectStyle>
+      </a:effectStyleLst>
+      <a:bgFillStyleLst>
+        <a:solidFill>
+          <a:schemeClr val="phClr"/>
+        </a:solidFill>
+        <a:solidFill>
+          <a:schemeClr val="phClr">
+            <a:tint val="95000"/>
+            <a:satMod val="170000"/>
+          </a:schemeClr>
+        </a:solidFill>
+        <a:gradFill rotWithShape="1">
+          <a:gsLst>
+            <a:gs pos="0">
+              <a:schemeClr val="phClr">
+                <a:tint val="93000"/>
+                <a:shade val="98000"/>
+                <a:lumMod val="102000"/>
+                <a:satMod val="150000"/>
+              </a:schemeClr>
+            </a:gs>
+            <a:gs pos="50000">
+              <a:schemeClr val="phClr">
+                <a:tint val="98000"/>
+                <a:shade val="90000"/>
+                <a:lumMod val="103000"/>
+                <a:satMod val="130000"/>
+              </a:schemeClr>
+            </a:gs>
+            <a:gs pos="100000">
+              <a:schemeClr val="phClr">
+                <a:shade val="63000"/>
+                <a:satMod val="120000"/>
+              </a:schemeClr>
+            </a:gs>
+          </a:gsLst>
+          <a:lin ang="5400000" scaled="0"/>
+        </a:gradFill>
+      </a:bgFillStyleLst>
+    </a:fmtScheme>
+  </a:themeElements>
+  <a:objectDefaults/>
+  <a:extraClrSchemeLst/>
 </a:theme>
 </file>
</xml_diff>

<commit_message>
docs: refresh user guides and screenshots
</commit_message>
<xml_diff>
--- a/assets/docs-image-source.pptx
+++ b/assets/docs-image-source.pptx
@@ -15,7 +15,7 @@
     <p:sldId id="260" r:id="rId6"/>
     <p:sldId id="261" r:id="rId7"/>
   </p:sldIdLst>
-  <p:sldSz cx="12192000" cy="6858000"/>
+  <p:sldSz cx="11585575" cy="6858000"/>
   <p:notesSz cx="6858000" cy="9144000"/>
   <p:defaultTextStyle>
     <a:defPPr>
@@ -818,8 +818,8 @@
         </p:nvSpPr>
         <p:spPr>
           <a:xfrm>
-            <a:off x="1524000" y="1122363"/>
-            <a:ext cx="9144000" cy="2387600"/>
+            <a:off x="1448197" y="1122363"/>
+            <a:ext cx="8689181" cy="2387600"/>
           </a:xfrm>
         </p:spPr>
         <p:txBody>
@@ -855,8 +855,8 @@
         </p:nvSpPr>
         <p:spPr>
           <a:xfrm>
-            <a:off x="1524000" y="3602038"/>
-            <a:ext cx="9144000" cy="1655762"/>
+            <a:off x="1448197" y="3602038"/>
+            <a:ext cx="8689181" cy="1655762"/>
           </a:xfrm>
         </p:spPr>
         <p:txBody>
@@ -1225,8 +1225,8 @@
         </p:nvSpPr>
         <p:spPr>
           <a:xfrm>
-            <a:off x="8724900" y="365125"/>
-            <a:ext cx="2628900" cy="5811838"/>
+            <a:off x="8290928" y="365125"/>
+            <a:ext cx="2498139" cy="5811838"/>
           </a:xfrm>
         </p:spPr>
         <p:txBody>
@@ -1257,8 +1257,8 @@
         </p:nvSpPr>
         <p:spPr>
           <a:xfrm>
-            <a:off x="838200" y="365125"/>
-            <a:ext cx="7734300" cy="5811838"/>
+            <a:off x="796509" y="365125"/>
+            <a:ext cx="7349599" cy="5811838"/>
           </a:xfrm>
         </p:spPr>
         <p:txBody>
@@ -1625,8 +1625,8 @@
         </p:nvSpPr>
         <p:spPr>
           <a:xfrm>
-            <a:off x="831850" y="1709738"/>
-            <a:ext cx="10515600" cy="2852737"/>
+            <a:off x="790475" y="1709740"/>
+            <a:ext cx="9992558" cy="2852737"/>
           </a:xfrm>
         </p:spPr>
         <p:txBody>
@@ -1662,8 +1662,8 @@
         </p:nvSpPr>
         <p:spPr>
           <a:xfrm>
-            <a:off x="831850" y="4589463"/>
-            <a:ext cx="10515600" cy="1500187"/>
+            <a:off x="790475" y="4589465"/>
+            <a:ext cx="9992558" cy="1500187"/>
           </a:xfrm>
         </p:spPr>
         <p:txBody>
@@ -1921,8 +1921,8 @@
         </p:nvSpPr>
         <p:spPr>
           <a:xfrm>
-            <a:off x="838200" y="1825625"/>
-            <a:ext cx="5181600" cy="4351338"/>
+            <a:off x="796508" y="1825625"/>
+            <a:ext cx="4923870" cy="4351338"/>
           </a:xfrm>
         </p:spPr>
         <p:txBody>
@@ -1988,8 +1988,8 @@
         </p:nvSpPr>
         <p:spPr>
           <a:xfrm>
-            <a:off x="6172200" y="1825625"/>
-            <a:ext cx="5181600" cy="4351338"/>
+            <a:off x="5865197" y="1825625"/>
+            <a:ext cx="4923870" cy="4351338"/>
           </a:xfrm>
         </p:spPr>
         <p:txBody>
@@ -2161,8 +2161,8 @@
         </p:nvSpPr>
         <p:spPr>
           <a:xfrm>
-            <a:off x="839788" y="365125"/>
-            <a:ext cx="10515600" cy="1325563"/>
+            <a:off x="798018" y="365127"/>
+            <a:ext cx="9992558" cy="1325563"/>
           </a:xfrm>
         </p:spPr>
         <p:txBody>
@@ -2193,8 +2193,8 @@
         </p:nvSpPr>
         <p:spPr>
           <a:xfrm>
-            <a:off x="839788" y="1681163"/>
-            <a:ext cx="5157787" cy="823912"/>
+            <a:off x="798018" y="1681163"/>
+            <a:ext cx="4901241" cy="823912"/>
           </a:xfrm>
         </p:spPr>
         <p:txBody>
@@ -2265,8 +2265,8 @@
         </p:nvSpPr>
         <p:spPr>
           <a:xfrm>
-            <a:off x="839788" y="2505075"/>
-            <a:ext cx="5157787" cy="3684588"/>
+            <a:off x="798018" y="2505075"/>
+            <a:ext cx="4901241" cy="3684588"/>
           </a:xfrm>
         </p:spPr>
         <p:txBody>
@@ -2332,8 +2332,8 @@
         </p:nvSpPr>
         <p:spPr>
           <a:xfrm>
-            <a:off x="6172200" y="1681163"/>
-            <a:ext cx="5183188" cy="823912"/>
+            <a:off x="5865197" y="1681163"/>
+            <a:ext cx="4925379" cy="823912"/>
           </a:xfrm>
         </p:spPr>
         <p:txBody>
@@ -2404,8 +2404,8 @@
         </p:nvSpPr>
         <p:spPr>
           <a:xfrm>
-            <a:off x="6172200" y="2505075"/>
-            <a:ext cx="5183188" cy="3684588"/>
+            <a:off x="5865197" y="2505075"/>
+            <a:ext cx="4925379" cy="3684588"/>
           </a:xfrm>
         </p:spPr>
         <p:txBody>
@@ -2816,8 +2816,8 @@
         </p:nvSpPr>
         <p:spPr>
           <a:xfrm>
-            <a:off x="839788" y="457200"/>
-            <a:ext cx="3932237" cy="1600200"/>
+            <a:off x="798018" y="457200"/>
+            <a:ext cx="3736650" cy="1600200"/>
           </a:xfrm>
         </p:spPr>
         <p:txBody>
@@ -2853,8 +2853,8 @@
         </p:nvSpPr>
         <p:spPr>
           <a:xfrm>
-            <a:off x="5183188" y="987425"/>
-            <a:ext cx="6172200" cy="4873625"/>
+            <a:off x="4925379" y="987427"/>
+            <a:ext cx="5865197" cy="4873625"/>
           </a:xfrm>
         </p:spPr>
         <p:txBody>
@@ -2957,8 +2957,8 @@
         </p:nvSpPr>
         <p:spPr>
           <a:xfrm>
-            <a:off x="839788" y="2057400"/>
-            <a:ext cx="3932237" cy="3811588"/>
+            <a:off x="798018" y="2057400"/>
+            <a:ext cx="3736650" cy="3811588"/>
           </a:xfrm>
         </p:spPr>
         <p:txBody>
@@ -3135,8 +3135,8 @@
         </p:nvSpPr>
         <p:spPr>
           <a:xfrm>
-            <a:off x="839788" y="457200"/>
-            <a:ext cx="3932237" cy="1600200"/>
+            <a:off x="798018" y="457200"/>
+            <a:ext cx="3736650" cy="1600200"/>
           </a:xfrm>
         </p:spPr>
         <p:txBody>
@@ -3172,8 +3172,8 @@
         </p:nvSpPr>
         <p:spPr>
           <a:xfrm>
-            <a:off x="5183188" y="987425"/>
-            <a:ext cx="6172200" cy="4873625"/>
+            <a:off x="4925379" y="987427"/>
+            <a:ext cx="5865197" cy="4873625"/>
           </a:xfrm>
         </p:spPr>
         <p:txBody>
@@ -3239,8 +3239,8 @@
         </p:nvSpPr>
         <p:spPr>
           <a:xfrm>
-            <a:off x="839788" y="2057400"/>
-            <a:ext cx="3932237" cy="3811588"/>
+            <a:off x="798018" y="2057400"/>
+            <a:ext cx="3736650" cy="3811588"/>
           </a:xfrm>
         </p:spPr>
         <p:txBody>
@@ -3422,8 +3422,8 @@
         </p:nvSpPr>
         <p:spPr>
           <a:xfrm>
-            <a:off x="838200" y="365125"/>
-            <a:ext cx="10515600" cy="1325563"/>
+            <a:off x="796509" y="365127"/>
+            <a:ext cx="9992558" cy="1325563"/>
           </a:xfrm>
           <a:prstGeom prst="rect">
             <a:avLst/>
@@ -3459,8 +3459,8 @@
         </p:nvSpPr>
         <p:spPr>
           <a:xfrm>
-            <a:off x="838200" y="1825625"/>
-            <a:ext cx="10515600" cy="4351338"/>
+            <a:off x="796509" y="1825625"/>
+            <a:ext cx="9992558" cy="4351338"/>
           </a:xfrm>
           <a:prstGeom prst="rect">
             <a:avLst/>
@@ -3531,8 +3531,8 @@
         </p:nvSpPr>
         <p:spPr>
           <a:xfrm>
-            <a:off x="838200" y="6356350"/>
-            <a:ext cx="2743200" cy="365125"/>
+            <a:off x="796509" y="6356352"/>
+            <a:ext cx="2606755" cy="365125"/>
           </a:xfrm>
           <a:prstGeom prst="rect">
             <a:avLst/>
@@ -3578,8 +3578,8 @@
         </p:nvSpPr>
         <p:spPr>
           <a:xfrm>
-            <a:off x="4038600" y="6356350"/>
-            <a:ext cx="4114800" cy="365125"/>
+            <a:off x="3837722" y="6356352"/>
+            <a:ext cx="3910132" cy="365125"/>
           </a:xfrm>
           <a:prstGeom prst="rect">
             <a:avLst/>
@@ -3622,8 +3622,8 @@
         </p:nvSpPr>
         <p:spPr>
           <a:xfrm>
-            <a:off x="8610600" y="6356350"/>
-            <a:ext cx="2743200" cy="365125"/>
+            <a:off x="8182312" y="6356352"/>
+            <a:ext cx="2606755" cy="365125"/>
           </a:xfrm>
           <a:prstGeom prst="rect">
             <a:avLst/>
@@ -3988,7 +3988,7 @@
         </p:blipFill>
         <p:spPr>
           <a:xfrm>
-            <a:off x="303906" y="0"/>
+            <a:off x="693" y="0"/>
             <a:ext cx="11584188" cy="6858000"/>
           </a:xfrm>
           <a:prstGeom prst="rect">
@@ -4012,7 +4012,7 @@
         </p:nvSpPr>
         <p:spPr>
           <a:xfrm>
-            <a:off x="1409888" y="728275"/>
+            <a:off x="1451731" y="1014449"/>
             <a:ext cx="3612962" cy="402026"/>
           </a:xfrm>
           <a:prstGeom prst="borderCallout2">
@@ -4075,7 +4075,7 @@
         </p:nvSpPr>
         <p:spPr>
           <a:xfrm>
-            <a:off x="1644579" y="1858576"/>
+            <a:off x="1962470" y="2104675"/>
             <a:ext cx="2234681" cy="402026"/>
           </a:xfrm>
           <a:prstGeom prst="borderCallout2">
@@ -4117,7 +4117,16 @@
               <a:buNone/>
             </a:pPr>
             <a:r>
-              <a:t>3. 解析 / Analyze</a:t>
+              <a:rPr dirty="0"/>
+              <a:t>3. </a:t>
+            </a:r>
+            <a:r>
+              <a:rPr dirty="0" err="1"/>
+              <a:t>解析</a:t>
+            </a:r>
+            <a:r>
+              <a:rPr dirty="0"/>
+              <a:t> / Analyze</a:t>
             </a:r>
           </a:p>
         </p:txBody>
@@ -4138,8 +4147,8 @@
         </p:nvSpPr>
         <p:spPr>
           <a:xfrm>
-            <a:off x="1927551" y="3292550"/>
-            <a:ext cx="4110736" cy="450800"/>
+            <a:off x="2101666" y="3883101"/>
+            <a:ext cx="6187030" cy="450800"/>
           </a:xfrm>
           <a:prstGeom prst="borderCallout1">
             <a:avLst>
@@ -4178,8 +4187,30 @@
               <a:buNone/>
             </a:pPr>
             <a:r>
-              <a:t>2. ガイドを貼る / Paste guide</a:t>
-            </a:r>
+              <a:rPr dirty="0"/>
+              <a:t>2. </a:t>
+            </a:r>
+            <a:r>
+              <a:rPr lang="ja-JP" altLang="en-US" dirty="0"/>
+              <a:t>タイムスタンプを貼付</a:t>
+            </a:r>
+            <a:r>
+              <a:rPr dirty="0"/>
+              <a:t> / Paste </a:t>
+            </a:r>
+            <a:r>
+              <a:rPr lang="en-US" altLang="ja-JP" dirty="0"/>
+              <a:t>TS</a:t>
+            </a:r>
+            <a:r>
+              <a:rPr lang="ja-JP" altLang="en-US" dirty="0"/>
+              <a:t> </a:t>
+            </a:r>
+            <a:r>
+              <a:rPr lang="en-US" altLang="ja-JP" dirty="0"/>
+              <a:t>comments</a:t>
+            </a:r>
+            <a:endParaRPr dirty="0"/>
           </a:p>
         </p:txBody>
       </p:sp>
@@ -4228,7 +4259,7 @@
         </p:blipFill>
         <p:spPr>
           <a:xfrm>
-            <a:off x="303906" y="0"/>
+            <a:off x="693" y="0"/>
             <a:ext cx="11584188" cy="6858000"/>
           </a:xfrm>
           <a:prstGeom prst="rect">
@@ -4252,7 +4283,7 @@
         </p:nvSpPr>
         <p:spPr>
           <a:xfrm>
-            <a:off x="6023058" y="4838939"/>
+            <a:off x="6986456" y="5921913"/>
             <a:ext cx="3174718" cy="678612"/>
           </a:xfrm>
           <a:prstGeom prst="borderCallout2">
@@ -4294,7 +4325,16 @@
               <a:buNone/>
             </a:pPr>
             <a:r>
-              <a:t>1. セグメントを選択 / Select</a:t>
+              <a:rPr dirty="0"/>
+              <a:t>1. </a:t>
+            </a:r>
+            <a:r>
+              <a:rPr dirty="0" err="1"/>
+              <a:t>セグメントを選択</a:t>
+            </a:r>
+            <a:r>
+              <a:rPr dirty="0"/>
+              <a:t> / Select</a:t>
             </a:r>
           </a:p>
         </p:txBody>
@@ -4315,8 +4355,8 @@
         </p:nvSpPr>
         <p:spPr>
           <a:xfrm>
-            <a:off x="1746495" y="4794728"/>
-            <a:ext cx="2605374" cy="678612"/>
+            <a:off x="2001123" y="5921913"/>
+            <a:ext cx="3561626" cy="678612"/>
           </a:xfrm>
           <a:prstGeom prst="borderCallout2">
             <a:avLst>
@@ -4378,8 +4418,8 @@
         </p:nvSpPr>
         <p:spPr>
           <a:xfrm>
-            <a:off x="7768609" y="3678208"/>
-            <a:ext cx="3344370" cy="678612"/>
+            <a:off x="6174603" y="4499152"/>
+            <a:ext cx="3829457" cy="678612"/>
           </a:xfrm>
           <a:prstGeom prst="borderCallout2">
             <a:avLst>
@@ -4441,8 +4481,8 @@
         </p:nvSpPr>
         <p:spPr>
           <a:xfrm>
-            <a:off x="1309101" y="5780177"/>
-            <a:ext cx="2605374" cy="678612"/>
+            <a:off x="3390874" y="3156189"/>
+            <a:ext cx="3561625" cy="678612"/>
           </a:xfrm>
           <a:prstGeom prst="borderCallout2">
             <a:avLst>
@@ -4483,7 +4523,16 @@
               <a:buNone/>
             </a:pPr>
             <a:r>
-              <a:t>4. 書き出し対象 / Export</a:t>
+              <a:rPr dirty="0"/>
+              <a:t>4. </a:t>
+            </a:r>
+            <a:r>
+              <a:rPr dirty="0" err="1"/>
+              <a:t>書き出し</a:t>
+            </a:r>
+            <a:r>
+              <a:rPr dirty="0"/>
+              <a:t> / Export</a:t>
             </a:r>
           </a:p>
         </p:txBody>
@@ -4528,13 +4577,15 @@
         </p:nvPicPr>
         <p:blipFill>
           <a:blip r:embed="rId3"/>
-          <a:srcRect l="49476" b="43983"/>
-          <a:stretch/>
+          <a:srcRect l="47634" b="43983"/>
+          <a:stretch>
+            <a:fillRect/>
+          </a:stretch>
         </p:blipFill>
         <p:spPr>
           <a:xfrm>
-            <a:off x="710143" y="0"/>
-            <a:ext cx="11158937" cy="6858000"/>
+            <a:off x="0" y="0"/>
+            <a:ext cx="11565869" cy="6858000"/>
           </a:xfrm>
           <a:prstGeom prst="rect">
             <a:avLst/>
@@ -4557,7 +4608,7 @@
         </p:nvSpPr>
         <p:spPr>
           <a:xfrm>
-            <a:off x="1037686" y="3710257"/>
+            <a:off x="734473" y="3710257"/>
             <a:ext cx="2421146" cy="678612"/>
           </a:xfrm>
           <a:prstGeom prst="borderCallout1">
@@ -4623,7 +4674,7 @@
         </p:nvSpPr>
         <p:spPr>
           <a:xfrm>
-            <a:off x="3786375" y="3710257"/>
+            <a:off x="3483162" y="3710257"/>
             <a:ext cx="3039668" cy="678612"/>
           </a:xfrm>
           <a:prstGeom prst="borderCallout1">
@@ -4663,7 +4714,11 @@
               <a:buNone/>
             </a:pPr>
             <a:r>
-              <a:t>境界を微調整 / Nudge</a:t>
+              <a:t>境界を微調整</a:t>
+            </a:r>
+            <a:r>
+              <a:rPr dirty="0"/>
+              <a:t> / Nudge</a:t>
             </a:r>
           </a:p>
         </p:txBody>
@@ -4684,7 +4739,7 @@
         </p:nvSpPr>
         <p:spPr>
           <a:xfrm>
-            <a:off x="5877464" y="5561139"/>
+            <a:off x="5574251" y="5561139"/>
             <a:ext cx="2055964" cy="678612"/>
           </a:xfrm>
           <a:prstGeom prst="borderCallout1">
@@ -4745,8 +4800,8 @@
         </p:nvSpPr>
         <p:spPr>
           <a:xfrm>
-            <a:off x="9330726" y="5561139"/>
-            <a:ext cx="2055964" cy="678612"/>
+            <a:off x="8403771" y="5561139"/>
+            <a:ext cx="2679706" cy="678612"/>
           </a:xfrm>
           <a:prstGeom prst="borderCallout1">
             <a:avLst>
@@ -4840,7 +4895,7 @@
         </p:blipFill>
         <p:spPr>
           <a:xfrm>
-            <a:off x="303906" y="0"/>
+            <a:off x="693" y="0"/>
             <a:ext cx="11584188" cy="6858000"/>
           </a:xfrm>
           <a:prstGeom prst="rect">
@@ -4893,7 +4948,7 @@
         </p:blipFill>
         <p:spPr>
           <a:xfrm>
-            <a:off x="303906" y="0"/>
+            <a:off x="693" y="0"/>
             <a:ext cx="11584188" cy="6858000"/>
           </a:xfrm>
           <a:prstGeom prst="rect">
@@ -4917,7 +4972,7 @@
         </p:nvSpPr>
         <p:spPr>
           <a:xfrm>
-            <a:off x="2483038" y="994975"/>
+            <a:off x="2179825" y="994975"/>
             <a:ext cx="3612962" cy="402026"/>
           </a:xfrm>
           <a:prstGeom prst="borderCallout2">
@@ -4980,7 +5035,7 @@
         </p:nvSpPr>
         <p:spPr>
           <a:xfrm>
-            <a:off x="6493709" y="4677976"/>
+            <a:off x="6190498" y="4677976"/>
             <a:ext cx="3221791" cy="402026"/>
           </a:xfrm>
           <a:prstGeom prst="borderCallout2">
@@ -5057,7 +5112,7 @@
         </p:nvSpPr>
         <p:spPr>
           <a:xfrm>
-            <a:off x="2048201" y="3902100"/>
+            <a:off x="1744988" y="3902100"/>
             <a:ext cx="4110736" cy="450800"/>
           </a:xfrm>
           <a:prstGeom prst="borderCallout1">
@@ -5147,7 +5202,7 @@
         </p:blipFill>
         <p:spPr>
           <a:xfrm>
-            <a:off x="303906" y="0"/>
+            <a:off x="693" y="0"/>
             <a:ext cx="11584188" cy="6858000"/>
           </a:xfrm>
           <a:prstGeom prst="rect">

</xml_diff>